<commit_message>
Simplify Q&A presenter and add closing photo backdrop
</commit_message>
<xml_diff>
--- a/output/pptx/sdlcai-2026-outro.pptx
+++ b/output/pptx/sdlcai-2026-outro.pptx
@@ -2,19 +2,20 @@
 <file path=ppt/presentation.xml><?xml version="1.0" encoding="utf-8"?>
 <p:presentation xmlns:p="http://schemas.openxmlformats.org/presentationml/2006/main" embedTrueTypeFonts="1" saveSubsetFonts="0">
   <p:sldMasterIdLst>
-    <p:sldMasterId xmlns:r="http://schemas.openxmlformats.org/officeDocument/2006/relationships" id="2147483648" r:id="R23c2a0bd66bb412c"/>
+    <p:sldMasterId xmlns:r="http://schemas.openxmlformats.org/officeDocument/2006/relationships" id="2147483648" r:id="Rdd3a091543544982"/>
   </p:sldMasterIdLst>
   <p:notesMasterIdLst>
-    <p:notesMasterId xmlns:r="http://schemas.openxmlformats.org/officeDocument/2006/relationships" r:id="R621415af9df941bc"/>
+    <p:notesMasterId xmlns:r="http://schemas.openxmlformats.org/officeDocument/2006/relationships" r:id="Rd9b66c71230949a1"/>
   </p:notesMasterIdLst>
   <p:sldIdLst>
-    <p:sldId xmlns:r="http://schemas.openxmlformats.org/officeDocument/2006/relationships" id="256" r:id="R9854faf79ad64042"/>
-    <p:sldId xmlns:r="http://schemas.openxmlformats.org/officeDocument/2006/relationships" id="257" r:id="R1b534478b46a456d"/>
-    <p:sldId xmlns:r="http://schemas.openxmlformats.org/officeDocument/2006/relationships" id="258" r:id="R5a92102525fa453f"/>
-    <p:sldId xmlns:r="http://schemas.openxmlformats.org/officeDocument/2006/relationships" id="259" r:id="Rf7b9844d1c3c459d"/>
-    <p:sldId xmlns:r="http://schemas.openxmlformats.org/officeDocument/2006/relationships" id="260" r:id="Rcdec36d1bf0a4f2f"/>
-    <p:sldId xmlns:r="http://schemas.openxmlformats.org/officeDocument/2006/relationships" id="261" r:id="Rfd0f7f98871f4d13"/>
-    <p:sldId xmlns:r="http://schemas.openxmlformats.org/officeDocument/2006/relationships" id="262" r:id="Ra8f9f42fc9af4753"/>
+    <p:sldId xmlns:r="http://schemas.openxmlformats.org/officeDocument/2006/relationships" id="256" r:id="Ra67eafe42fee4ae4"/>
+    <p:sldId xmlns:r="http://schemas.openxmlformats.org/officeDocument/2006/relationships" id="257" r:id="R7a881237fabf46d2"/>
+    <p:sldId xmlns:r="http://schemas.openxmlformats.org/officeDocument/2006/relationships" id="258" r:id="R85d3e55f31b74274"/>
+    <p:sldId xmlns:r="http://schemas.openxmlformats.org/officeDocument/2006/relationships" id="259" r:id="Rbaab1c551cb94b58"/>
+    <p:sldId xmlns:r="http://schemas.openxmlformats.org/officeDocument/2006/relationships" id="260" r:id="R0ecbe8ece7cf4386"/>
+    <p:sldId xmlns:r="http://schemas.openxmlformats.org/officeDocument/2006/relationships" id="261" r:id="Rea5047963b3443cb"/>
+    <p:sldId xmlns:r="http://schemas.openxmlformats.org/officeDocument/2006/relationships" id="262" r:id="R4cf318cd3f6b405c"/>
+    <p:sldId xmlns:r="http://schemas.openxmlformats.org/officeDocument/2006/relationships" id="263" r:id="R617c9ce95d2741a3"/>
   </p:sldIdLst>
   <p:sldSz cx="18288000" cy="10287000"/>
   <p:notesSz cx="6858000" cy="9144000"/>
@@ -974,6 +975,91 @@
           </a:p>
           <a:p xmlns:a="http://schemas.openxmlformats.org/drawingml/2006/main">
             <a:r>
+              <a:t>https://sdlcai.org/slides/closing/#logo</a:t>
+            </a:r>
+          </a:p>
+          <a:p xmlns:a="http://schemas.openxmlformats.org/drawingml/2006/main">
+            <a:r>
+              <a:t>Local source: site/layouts/slide-closing.html</a:t>
+            </a:r>
+          </a:p>
+          <a:p xmlns:a="http://schemas.openxmlformats.org/drawingml/2006/main">
+            <a:r>
+              <a:t>Original speaker photographs and sponsor logos from assets/.</a:t>
+            </a:r>
+          </a:p>
+        </p:txBody>
+      </p:sp>
+      <p:sp>
+        <p:nvSpPr>
+          <p:cNvPr id="4" name="Slide Number Placeholder 3"/>
+          <p:cNvSpPr>
+            <a:spLocks xmlns:a="http://schemas.openxmlformats.org/drawingml/2006/main" noGrp="1"/>
+          </p:cNvSpPr>
+          <p:nvPr>
+            <p:ph type="sldNum" idx="5"/>
+          </p:nvPr>
+        </p:nvSpPr>
+        <p:spPr/>
+        <p:txBody>
+          <a:bodyPr xmlns:a="http://schemas.openxmlformats.org/drawingml/2006/main"/>
+          <a:lstStyle xmlns:a="http://schemas.openxmlformats.org/drawingml/2006/main"/>
+          <a:p xmlns:a="http://schemas.openxmlformats.org/drawingml/2006/main"/>
+        </p:txBody>
+      </p:sp>
+    </p:spTree>
+  </p:cSld>
+  <p:clrMapOvr>
+    <a:masterClrMapping xmlns:a="http://schemas.openxmlformats.org/drawingml/2006/main"/>
+  </p:clrMapOvr>
+</p:notes>
+</file>
+
+<file path=ppt/notesSlides/notesSlide8.xml><?xml version="1.0" encoding="utf-8"?>
+<p:notes xmlns:p="http://schemas.openxmlformats.org/presentationml/2006/main">
+  <p:cSld>
+    <p:spTree>
+      <p:nvGrpSpPr>
+        <p:cNvPr id="1" name=""/>
+        <p:cNvGrpSpPr/>
+        <p:nvPr/>
+      </p:nvGrpSpPr>
+      <p:grpSpPr>
+        <a:xfrm xmlns:a="http://schemas.openxmlformats.org/drawingml/2006/main"/>
+      </p:grpSpPr>
+      <p:sp>
+        <p:nvSpPr>
+          <p:cNvPr id="2" name="Slide Image Placeholder 1"/>
+          <p:cNvSpPr>
+            <a:spLocks xmlns:a="http://schemas.openxmlformats.org/drawingml/2006/main" noGrp="1"/>
+          </p:cNvSpPr>
+          <p:nvPr>
+            <p:ph type="sldImg" idx="0"/>
+          </p:nvPr>
+        </p:nvSpPr>
+        <p:spPr/>
+      </p:sp>
+      <p:sp>
+        <p:nvSpPr>
+          <p:cNvPr id="3" name="Notes Placeholder 2"/>
+          <p:cNvSpPr>
+            <a:spLocks xmlns:a="http://schemas.openxmlformats.org/drawingml/2006/main" noGrp="1"/>
+          </p:cNvSpPr>
+          <p:nvPr>
+            <p:ph type="body" idx="1"/>
+          </p:nvPr>
+        </p:nvSpPr>
+        <p:spPr/>
+        <p:txBody>
+          <a:bodyPr xmlns:a="http://schemas.openxmlformats.org/drawingml/2006/main"/>
+          <a:lstStyle xmlns:a="http://schemas.openxmlformats.org/drawingml/2006/main"/>
+          <a:p xmlns:a="http://schemas.openxmlformats.org/drawingml/2006/main">
+            <a:r>
+              <a:t>Source: SDLCAI closing slides</a:t>
+            </a:r>
+          </a:p>
+          <a:p xmlns:a="http://schemas.openxmlformats.org/drawingml/2006/main">
+            <a:r>
               <a:t>https://sdlcai.org/slides/closing/#afterparty</a:t>
             </a:r>
           </a:p>
@@ -1031,7 +1117,7 @@
           <p:cNvPr id="3" name="Title">
             <a:extLst xmlns:a="http://schemas.openxmlformats.org/drawingml/2006/main">
               <a:ext uri="{FF2B5EF4-FFF2-40B4-BE49-F238E27FC236}">
-                <a16:creationId xmlns:a16="http://schemas.microsoft.com/office/drawing/2014/main" id="{664A05B4-7469-4B6D-8431-5D9F8351FF91}"/>
+                <a16:creationId xmlns:a16="http://schemas.microsoft.com/office/drawing/2014/main" id="{819462A7-A5A7-468E-8DA7-1553BE7F41C5}"/>
               </a:ext>
             </a:extLst>
           </p:cNvPr>
@@ -1188,7 +1274,7 @@
           <p:cNvPr id="2" name="Subtitle">
             <a:extLst xmlns:a="http://schemas.openxmlformats.org/drawingml/2006/main">
               <a:ext uri="{FF2B5EF4-FFF2-40B4-BE49-F238E27FC236}">
-                <a16:creationId xmlns:a16="http://schemas.microsoft.com/office/drawing/2014/main" id="{1109F4C1-3208-460D-9B8C-9A87B006A4DE}"/>
+                <a16:creationId xmlns:a16="http://schemas.microsoft.com/office/drawing/2014/main" id="{FB4A48D3-551A-4256-97D5-626A659FD9A1}"/>
               </a:ext>
             </a:extLst>
           </p:cNvPr>
@@ -1362,7 +1448,7 @@
           <p:cNvPr id="2" name="Section title">
             <a:extLst xmlns:a="http://schemas.openxmlformats.org/drawingml/2006/main">
               <a:ext uri="{FF2B5EF4-FFF2-40B4-BE49-F238E27FC236}">
-                <a16:creationId xmlns:a16="http://schemas.microsoft.com/office/drawing/2014/main" id="{50DA19B7-643F-4961-AEE9-28904C2005AB}"/>
+                <a16:creationId xmlns:a16="http://schemas.microsoft.com/office/drawing/2014/main" id="{8F0CAE1F-4BA9-463B-AA81-7CD217B62C5B}"/>
               </a:ext>
             </a:extLst>
           </p:cNvPr>
@@ -1536,7 +1622,7 @@
           <p:cNvPr id="3" name="Title">
             <a:extLst xmlns:a="http://schemas.openxmlformats.org/drawingml/2006/main">
               <a:ext uri="{FF2B5EF4-FFF2-40B4-BE49-F238E27FC236}">
-                <a16:creationId xmlns:a16="http://schemas.microsoft.com/office/drawing/2014/main" id="{B5C69E65-ABE7-435D-9C20-7CF024D73034}"/>
+                <a16:creationId xmlns:a16="http://schemas.microsoft.com/office/drawing/2014/main" id="{C33DF845-0D5D-4266-8B07-5AAE4F441E2B}"/>
               </a:ext>
             </a:extLst>
           </p:cNvPr>
@@ -1693,7 +1779,7 @@
           <p:cNvPr id="2" name="Body">
             <a:extLst xmlns:a="http://schemas.openxmlformats.org/drawingml/2006/main">
               <a:ext uri="{FF2B5EF4-FFF2-40B4-BE49-F238E27FC236}">
-                <a16:creationId xmlns:a16="http://schemas.microsoft.com/office/drawing/2014/main" id="{BB90E7C3-0DFF-4834-A48D-B91C25EDB3FF}"/>
+                <a16:creationId xmlns:a16="http://schemas.microsoft.com/office/drawing/2014/main" id="{DFEAC29C-94B9-48C6-94F0-06CD20CE5B93}"/>
               </a:ext>
             </a:extLst>
           </p:cNvPr>
@@ -1867,7 +1953,7 @@
           <p:cNvPr id="4" name="Title">
             <a:extLst xmlns:a="http://schemas.openxmlformats.org/drawingml/2006/main">
               <a:ext uri="{FF2B5EF4-FFF2-40B4-BE49-F238E27FC236}">
-                <a16:creationId xmlns:a16="http://schemas.microsoft.com/office/drawing/2014/main" id="{148CD8A1-38D5-47CA-955D-8B18FD5875D9}"/>
+                <a16:creationId xmlns:a16="http://schemas.microsoft.com/office/drawing/2014/main" id="{D50066FB-EA02-4B3F-857A-18144D20BEAD}"/>
               </a:ext>
             </a:extLst>
           </p:cNvPr>
@@ -2024,7 +2110,7 @@
           <p:cNvPr id="2" name="Left column">
             <a:extLst xmlns:a="http://schemas.openxmlformats.org/drawingml/2006/main">
               <a:ext uri="{FF2B5EF4-FFF2-40B4-BE49-F238E27FC236}">
-                <a16:creationId xmlns:a16="http://schemas.microsoft.com/office/drawing/2014/main" id="{B130C4DE-8830-450E-945E-03DDC6F040CD}"/>
+                <a16:creationId xmlns:a16="http://schemas.microsoft.com/office/drawing/2014/main" id="{C9DDD7B2-38B8-4879-BCDF-19F4833F0338}"/>
               </a:ext>
             </a:extLst>
           </p:cNvPr>
@@ -2181,7 +2267,7 @@
           <p:cNvPr id="3" name="Right column">
             <a:extLst xmlns:a="http://schemas.openxmlformats.org/drawingml/2006/main">
               <a:ext uri="{FF2B5EF4-FFF2-40B4-BE49-F238E27FC236}">
-                <a16:creationId xmlns:a16="http://schemas.microsoft.com/office/drawing/2014/main" id="{0FA28B50-969E-402C-8E62-CC15FE6F9172}"/>
+                <a16:creationId xmlns:a16="http://schemas.microsoft.com/office/drawing/2014/main" id="{698DF8CA-F37A-4D44-AABB-3841A50C6C90}"/>
               </a:ext>
             </a:extLst>
           </p:cNvPr>
@@ -2355,7 +2441,7 @@
           <p:cNvPr id="3" name="Title">
             <a:extLst xmlns:a="http://schemas.openxmlformats.org/drawingml/2006/main">
               <a:ext uri="{FF2B5EF4-FFF2-40B4-BE49-F238E27FC236}">
-                <a16:creationId xmlns:a16="http://schemas.microsoft.com/office/drawing/2014/main" id="{8F4DF4EF-8F16-42F4-B522-20B277277190}"/>
+                <a16:creationId xmlns:a16="http://schemas.microsoft.com/office/drawing/2014/main" id="{28FE9F81-6913-4EC7-8788-00E87B08468A}"/>
               </a:ext>
             </a:extLst>
           </p:cNvPr>
@@ -2512,7 +2598,7 @@
           <p:cNvPr id="2" name="Left column">
             <a:extLst xmlns:a="http://schemas.openxmlformats.org/drawingml/2006/main">
               <a:ext uri="{FF2B5EF4-FFF2-40B4-BE49-F238E27FC236}">
-                <a16:creationId xmlns:a16="http://schemas.microsoft.com/office/drawing/2014/main" id="{2E18AED7-724E-4B73-9459-A86F43ACD6E7}"/>
+                <a16:creationId xmlns:a16="http://schemas.microsoft.com/office/drawing/2014/main" id="{CD16E2D4-4AA3-4A8C-8F4D-9BD6B70DD11B}"/>
               </a:ext>
             </a:extLst>
           </p:cNvPr>
@@ -2707,12 +2793,12 @@
   </p:cSld>
   <p:clrMap bg1="lt1" tx1="dk1" bg2="lt2" tx2="dk2" accent1="accent1" accent2="accent2" accent3="accent3" accent4="accent4" accent5="accent5" accent6="accent6" hlink="hlink" folHlink="folHlink"/>
   <p:sldLayoutIdLst>
-    <p:sldLayoutId xmlns:r="http://schemas.openxmlformats.org/officeDocument/2006/relationships" id="2147483649" r:id="R7a4ed31bbdf94684"/>
-    <p:sldLayoutId xmlns:r="http://schemas.openxmlformats.org/officeDocument/2006/relationships" id="2147483650" r:id="Ree829f5a678044a8"/>
-    <p:sldLayoutId xmlns:r="http://schemas.openxmlformats.org/officeDocument/2006/relationships" id="2147483651" r:id="Re32000e8d291422e"/>
-    <p:sldLayoutId xmlns:r="http://schemas.openxmlformats.org/officeDocument/2006/relationships" id="2147483652" r:id="R4b84631ae34b47ca"/>
-    <p:sldLayoutId xmlns:r="http://schemas.openxmlformats.org/officeDocument/2006/relationships" id="2147483653" r:id="Rd4ccf62db30f4bf7"/>
-    <p:sldLayoutId xmlns:r="http://schemas.openxmlformats.org/officeDocument/2006/relationships" id="2147483654" r:id="Rce6d36c075b84abd"/>
+    <p:sldLayoutId xmlns:r="http://schemas.openxmlformats.org/officeDocument/2006/relationships" id="2147483649" r:id="Rad9e42ab67a04d7f"/>
+    <p:sldLayoutId xmlns:r="http://schemas.openxmlformats.org/officeDocument/2006/relationships" id="2147483650" r:id="R04567268756740a5"/>
+    <p:sldLayoutId xmlns:r="http://schemas.openxmlformats.org/officeDocument/2006/relationships" id="2147483651" r:id="R104d37d8bd914dd2"/>
+    <p:sldLayoutId xmlns:r="http://schemas.openxmlformats.org/officeDocument/2006/relationships" id="2147483652" r:id="R3e4dab4b128a442b"/>
+    <p:sldLayoutId xmlns:r="http://schemas.openxmlformats.org/officeDocument/2006/relationships" id="2147483653" r:id="Rb1f181910c024342"/>
+    <p:sldLayoutId xmlns:r="http://schemas.openxmlformats.org/officeDocument/2006/relationships" id="2147483654" r:id="R5f8ca83b276347df"/>
   </p:sldLayoutIdLst>
   <p:txStyles>
     <p:titleStyle>
@@ -3263,7 +3349,7 @@
           <p:cNvPr id="16" name="">
             <a:extLst xmlns:a="http://schemas.openxmlformats.org/drawingml/2006/main">
               <a:ext uri="{FF2B5EF4-FFF2-40B4-BE49-F238E27FC236}">
-                <a16:creationId xmlns:a16="http://schemas.microsoft.com/office/drawing/2014/main" id="{2DC88ABC-61B0-4D31-989D-6F346A8137F2}"/>
+                <a16:creationId xmlns:a16="http://schemas.microsoft.com/office/drawing/2014/main" id="{7DC3FAAF-6BEF-4EF6-ACA8-8675BF54B13C}"/>
               </a:ext>
             </a:extLst>
           </p:cNvPr>
@@ -3273,7 +3359,7 @@
           <p:nvPr/>
         </p:nvPicPr>
         <p:blipFill>
-          <a:blip xmlns:r="http://schemas.openxmlformats.org/officeDocument/2006/relationships" xmlns:a="http://schemas.openxmlformats.org/drawingml/2006/main" r:embed="R7b59d57238e24463"/>
+          <a:blip xmlns:r="http://schemas.openxmlformats.org/officeDocument/2006/relationships" xmlns:a="http://schemas.openxmlformats.org/drawingml/2006/main" r:embed="R53ab902e7d4d457d"/>
           <a:stretch xmlns:a="http://schemas.openxmlformats.org/drawingml/2006/main"/>
         </p:blipFill>
         <p:spPr>
@@ -3291,7 +3377,7 @@
           <p:cNvPr id="2" name="recap-span-1">
             <a:extLst xmlns:a="http://schemas.openxmlformats.org/drawingml/2006/main">
               <a:ext uri="{FF2B5EF4-FFF2-40B4-BE49-F238E27FC236}">
-                <a16:creationId xmlns:a16="http://schemas.microsoft.com/office/drawing/2014/main" id="{9FD4B70A-31B9-4BD2-BB57-B4945494CBE8}"/>
+                <a16:creationId xmlns:a16="http://schemas.microsoft.com/office/drawing/2014/main" id="{F51F7C7B-F988-45CA-8BF0-A2670B58D7D4}"/>
               </a:ext>
             </a:extLst>
           </p:cNvPr>
@@ -3359,7 +3445,7 @@
           <p:cNvPr id="3" name="recap-span-2">
             <a:extLst xmlns:a="http://schemas.openxmlformats.org/drawingml/2006/main">
               <a:ext uri="{FF2B5EF4-FFF2-40B4-BE49-F238E27FC236}">
-                <a16:creationId xmlns:a16="http://schemas.microsoft.com/office/drawing/2014/main" id="{8291E08E-2884-4030-B16F-10636FE139D6}"/>
+                <a16:creationId xmlns:a16="http://schemas.microsoft.com/office/drawing/2014/main" id="{BAEAD104-909F-4DAA-BC3F-2B042CF32F1E}"/>
               </a:ext>
             </a:extLst>
           </p:cNvPr>
@@ -3427,7 +3513,7 @@
           <p:cNvPr id="4" name="recap-h1-3">
             <a:extLst xmlns:a="http://schemas.openxmlformats.org/drawingml/2006/main">
               <a:ext uri="{FF2B5EF4-FFF2-40B4-BE49-F238E27FC236}">
-                <a16:creationId xmlns:a16="http://schemas.microsoft.com/office/drawing/2014/main" id="{0821A094-507C-464A-946F-FD1C617713C7}"/>
+                <a16:creationId xmlns:a16="http://schemas.microsoft.com/office/drawing/2014/main" id="{1FE137E1-98ED-485E-8904-9B7A6082A910}"/>
               </a:ext>
             </a:extLst>
           </p:cNvPr>
@@ -3495,7 +3581,7 @@
           <p:cNvPr id="5" name="recap-span-4">
             <a:extLst xmlns:a="http://schemas.openxmlformats.org/drawingml/2006/main">
               <a:ext uri="{FF2B5EF4-FFF2-40B4-BE49-F238E27FC236}">
-                <a16:creationId xmlns:a16="http://schemas.microsoft.com/office/drawing/2014/main" id="{12CE0D73-CE12-4144-B586-87089A70669B}"/>
+                <a16:creationId xmlns:a16="http://schemas.microsoft.com/office/drawing/2014/main" id="{7A24DEA8-A157-4FDD-B1A3-3CAF392E07F6}"/>
               </a:ext>
             </a:extLst>
           </p:cNvPr>
@@ -3563,7 +3649,7 @@
           <p:cNvPr id="6" name="recap-strong-5">
             <a:extLst xmlns:a="http://schemas.openxmlformats.org/drawingml/2006/main">
               <a:ext uri="{FF2B5EF4-FFF2-40B4-BE49-F238E27FC236}">
-                <a16:creationId xmlns:a16="http://schemas.microsoft.com/office/drawing/2014/main" id="{9D20178F-E199-41A3-816A-FC869250A712}"/>
+                <a16:creationId xmlns:a16="http://schemas.microsoft.com/office/drawing/2014/main" id="{FA8B9599-F71A-4433-A739-DA8E887FDBB1}"/>
               </a:ext>
             </a:extLst>
           </p:cNvPr>
@@ -3631,7 +3717,7 @@
           <p:cNvPr id="7" name="recap-span-6">
             <a:extLst xmlns:a="http://schemas.openxmlformats.org/drawingml/2006/main">
               <a:ext uri="{FF2B5EF4-FFF2-40B4-BE49-F238E27FC236}">
-                <a16:creationId xmlns:a16="http://schemas.microsoft.com/office/drawing/2014/main" id="{3D094B73-F691-4589-A7EE-41DF82CA2CC8}"/>
+                <a16:creationId xmlns:a16="http://schemas.microsoft.com/office/drawing/2014/main" id="{8E323965-2311-44F4-B06B-53031433A5B0}"/>
               </a:ext>
             </a:extLst>
           </p:cNvPr>
@@ -3699,7 +3785,7 @@
           <p:cNvPr id="8" name="recap-strong-7">
             <a:extLst xmlns:a="http://schemas.openxmlformats.org/drawingml/2006/main">
               <a:ext uri="{FF2B5EF4-FFF2-40B4-BE49-F238E27FC236}">
-                <a16:creationId xmlns:a16="http://schemas.microsoft.com/office/drawing/2014/main" id="{E91A6B56-C3A7-42FF-B5AF-B65E3732FF8D}"/>
+                <a16:creationId xmlns:a16="http://schemas.microsoft.com/office/drawing/2014/main" id="{05329C29-1FA9-4140-A059-824780D6C72B}"/>
               </a:ext>
             </a:extLst>
           </p:cNvPr>
@@ -3767,7 +3853,7 @@
           <p:cNvPr id="9" name="recap-strong-8">
             <a:extLst xmlns:a="http://schemas.openxmlformats.org/drawingml/2006/main">
               <a:ext uri="{FF2B5EF4-FFF2-40B4-BE49-F238E27FC236}">
-                <a16:creationId xmlns:a16="http://schemas.microsoft.com/office/drawing/2014/main" id="{C9FFFB37-58E2-421D-8F53-8C449F76439B}"/>
+                <a16:creationId xmlns:a16="http://schemas.microsoft.com/office/drawing/2014/main" id="{B79D0513-58C4-421A-B8C4-1D8F2531BCFD}"/>
               </a:ext>
             </a:extLst>
           </p:cNvPr>
@@ -3835,7 +3921,7 @@
           <p:cNvPr id="10" name="recap-span-9">
             <a:extLst xmlns:a="http://schemas.openxmlformats.org/drawingml/2006/main">
               <a:ext uri="{FF2B5EF4-FFF2-40B4-BE49-F238E27FC236}">
-                <a16:creationId xmlns:a16="http://schemas.microsoft.com/office/drawing/2014/main" id="{0FA34E13-5D31-4025-9815-66ADEBABDE76}"/>
+                <a16:creationId xmlns:a16="http://schemas.microsoft.com/office/drawing/2014/main" id="{F6992CE6-5100-47AC-8FDC-0328F837916D}"/>
               </a:ext>
             </a:extLst>
           </p:cNvPr>
@@ -3903,7 +3989,7 @@
           <p:cNvPr id="11" name="recap-strong-10">
             <a:extLst xmlns:a="http://schemas.openxmlformats.org/drawingml/2006/main">
               <a:ext uri="{FF2B5EF4-FFF2-40B4-BE49-F238E27FC236}">
-                <a16:creationId xmlns:a16="http://schemas.microsoft.com/office/drawing/2014/main" id="{CC40A8FB-1D95-462F-B5E6-EADD2DCF4FC6}"/>
+                <a16:creationId xmlns:a16="http://schemas.microsoft.com/office/drawing/2014/main" id="{5C9E3EA5-2E09-4963-A4A8-FE1DC64BF519}"/>
               </a:ext>
             </a:extLst>
           </p:cNvPr>
@@ -3971,7 +4057,7 @@
           <p:cNvPr id="12" name="recap-strong-11">
             <a:extLst xmlns:a="http://schemas.openxmlformats.org/drawingml/2006/main">
               <a:ext uri="{FF2B5EF4-FFF2-40B4-BE49-F238E27FC236}">
-                <a16:creationId xmlns:a16="http://schemas.microsoft.com/office/drawing/2014/main" id="{7AF3693B-5E70-4B8F-ADA6-C7DE71658581}"/>
+                <a16:creationId xmlns:a16="http://schemas.microsoft.com/office/drawing/2014/main" id="{FDB57CEA-D71A-476D-8C0D-007B8CD849C9}"/>
               </a:ext>
             </a:extLst>
           </p:cNvPr>
@@ -4039,7 +4125,7 @@
           <p:cNvPr id="13" name="recap-p-12">
             <a:extLst xmlns:a="http://schemas.openxmlformats.org/drawingml/2006/main">
               <a:ext uri="{FF2B5EF4-FFF2-40B4-BE49-F238E27FC236}">
-                <a16:creationId xmlns:a16="http://schemas.microsoft.com/office/drawing/2014/main" id="{E4EE771B-DB95-439D-B63E-915DC8A61B8B}"/>
+                <a16:creationId xmlns:a16="http://schemas.microsoft.com/office/drawing/2014/main" id="{D9D18876-775B-499E-8993-83CA5505FA15}"/>
               </a:ext>
             </a:extLst>
           </p:cNvPr>
@@ -4107,7 +4193,7 @@
           <p:cNvPr id="14" name="recap-span-13">
             <a:extLst xmlns:a="http://schemas.openxmlformats.org/drawingml/2006/main">
               <a:ext uri="{FF2B5EF4-FFF2-40B4-BE49-F238E27FC236}">
-                <a16:creationId xmlns:a16="http://schemas.microsoft.com/office/drawing/2014/main" id="{127DE627-F90E-41D2-B50B-9A08B3D50763}"/>
+                <a16:creationId xmlns:a16="http://schemas.microsoft.com/office/drawing/2014/main" id="{903EB272-7C46-4E50-B66D-237761841DE1}"/>
               </a:ext>
             </a:extLst>
           </p:cNvPr>
@@ -4175,19 +4261,19 @@
           <p:cNvPr id="15" name="recap-span-14">
             <a:extLst xmlns:a="http://schemas.openxmlformats.org/drawingml/2006/main">
               <a:ext uri="{FF2B5EF4-FFF2-40B4-BE49-F238E27FC236}">
-                <a16:creationId xmlns:a16="http://schemas.microsoft.com/office/drawing/2014/main" id="{EA1401BF-B66F-4089-A6A7-2B211E12A58B}"/>
-              </a:ext>
-            </a:extLst>
-          </p:cNvPr>
-          <p:cNvSpPr>
-            <a:spLocks xmlns:a="http://schemas.openxmlformats.org/drawingml/2006/main" noGrp="1"/>
-          </p:cNvSpPr>
-          <p:nvPr/>
-        </p:nvSpPr>
-        <p:spPr>
-          <a:xfrm xmlns:a="http://schemas.openxmlformats.org/drawingml/2006/main">
-            <a:off x="17025938" y="9440446"/>
-            <a:ext cx="667792" cy="230662"/>
+                <a16:creationId xmlns:a16="http://schemas.microsoft.com/office/drawing/2014/main" id="{38A9141F-6528-42E6-8326-F7022CA90D80}"/>
+              </a:ext>
+            </a:extLst>
+          </p:cNvPr>
+          <p:cNvSpPr>
+            <a:spLocks xmlns:a="http://schemas.openxmlformats.org/drawingml/2006/main" noGrp="1"/>
+          </p:cNvSpPr>
+          <p:nvPr/>
+        </p:nvSpPr>
+        <p:spPr>
+          <a:xfrm xmlns:a="http://schemas.openxmlformats.org/drawingml/2006/main">
+            <a:off x="17021621" y="9440446"/>
+            <a:ext cx="672108" cy="230662"/>
           </a:xfrm>
           <a:prstGeom xmlns:a="http://schemas.openxmlformats.org/drawingml/2006/main" prst="rect">
             <a:avLst/>
@@ -4233,7 +4319,7 @@
                 <a:ea typeface="Finlandica Text"/>
                 <a:cs typeface="Finlandica Text"/>
               </a:rPr>
-              <a:t>1 / 7</a:t>
+              <a:t>1 / 8</a:t>
             </a:r>
           </a:p>
         </p:txBody>
@@ -4241,7 +4327,7 @@
     </p:spTree>
     <p:extLst>
       <p:ext uri="{BB962C8B-B14F-4D97-AF65-F5344CB8AC3E}">
-        <p14:creationId xmlns:p14="http://schemas.microsoft.com/office/powerpoint/2010/main" val="1912141114"/>
+        <p14:creationId xmlns:p14="http://schemas.microsoft.com/office/powerpoint/2010/main" val="2140944647"/>
       </p:ext>
     </p:extLst>
   </p:cSld>
@@ -4272,7 +4358,7 @@
           <p:cNvPr id="28" name="">
             <a:extLst xmlns:a="http://schemas.openxmlformats.org/drawingml/2006/main">
               <a:ext uri="{FF2B5EF4-FFF2-40B4-BE49-F238E27FC236}">
-                <a16:creationId xmlns:a16="http://schemas.microsoft.com/office/drawing/2014/main" id="{1454CDD2-0953-4B31-8F9A-BDF583E639CA}"/>
+                <a16:creationId xmlns:a16="http://schemas.microsoft.com/office/drawing/2014/main" id="{6AE105FD-E787-4603-BBC9-F27A2878C176}"/>
               </a:ext>
             </a:extLst>
           </p:cNvPr>
@@ -4282,7 +4368,7 @@
           <p:nvPr/>
         </p:nvPicPr>
         <p:blipFill>
-          <a:blip xmlns:r="http://schemas.openxmlformats.org/officeDocument/2006/relationships" xmlns:a="http://schemas.openxmlformats.org/drawingml/2006/main" r:embed="R208a231915f4454d"/>
+          <a:blip xmlns:r="http://schemas.openxmlformats.org/officeDocument/2006/relationships" xmlns:a="http://schemas.openxmlformats.org/drawingml/2006/main" r:embed="R58a011d343554c62"/>
           <a:stretch xmlns:a="http://schemas.openxmlformats.org/drawingml/2006/main"/>
         </p:blipFill>
         <p:spPr>
@@ -4300,7 +4386,7 @@
           <p:cNvPr id="2" name="">
             <a:extLst xmlns:a="http://schemas.openxmlformats.org/drawingml/2006/main">
               <a:ext uri="{FF2B5EF4-FFF2-40B4-BE49-F238E27FC236}">
-                <a16:creationId xmlns:a16="http://schemas.microsoft.com/office/drawing/2014/main" id="{3DDC8E58-7E60-45E9-BA9C-F19E2B9BA803}"/>
+                <a16:creationId xmlns:a16="http://schemas.microsoft.com/office/drawing/2014/main" id="{D40FF30D-D979-488B-AA62-BF58C82F0876}"/>
               </a:ext>
             </a:extLst>
           </p:cNvPr>
@@ -4310,7 +4396,7 @@
           <p:nvPr/>
         </p:nvPicPr>
         <p:blipFill>
-          <a:blip xmlns:r="http://schemas.openxmlformats.org/officeDocument/2006/relationships" xmlns:a="http://schemas.openxmlformats.org/drawingml/2006/main" r:embed="Rb62b0208cf754461"/>
+          <a:blip xmlns:r="http://schemas.openxmlformats.org/officeDocument/2006/relationships" xmlns:a="http://schemas.openxmlformats.org/drawingml/2006/main" r:embed="Rbfdf4329390240b4"/>
           <a:stretch xmlns:a="http://schemas.openxmlformats.org/drawingml/2006/main"/>
         </p:blipFill>
         <p:spPr>
@@ -4328,7 +4414,7 @@
           <p:cNvPr id="3" name="">
             <a:extLst xmlns:a="http://schemas.openxmlformats.org/drawingml/2006/main">
               <a:ext uri="{FF2B5EF4-FFF2-40B4-BE49-F238E27FC236}">
-                <a16:creationId xmlns:a16="http://schemas.microsoft.com/office/drawing/2014/main" id="{619EC3E8-D7B9-445E-B333-17AE644D6981}"/>
+                <a16:creationId xmlns:a16="http://schemas.microsoft.com/office/drawing/2014/main" id="{7547D8D9-DE04-419F-A859-7C9894B70C76}"/>
               </a:ext>
             </a:extLst>
           </p:cNvPr>
@@ -4338,7 +4424,7 @@
           <p:nvPr/>
         </p:nvPicPr>
         <p:blipFill>
-          <a:blip xmlns:r="http://schemas.openxmlformats.org/officeDocument/2006/relationships" xmlns:a="http://schemas.openxmlformats.org/drawingml/2006/main" r:embed="R9230bbba49d74ef9"/>
+          <a:blip xmlns:r="http://schemas.openxmlformats.org/officeDocument/2006/relationships" xmlns:a="http://schemas.openxmlformats.org/drawingml/2006/main" r:embed="R2d198c4500324f42"/>
           <a:stretch xmlns:a="http://schemas.openxmlformats.org/drawingml/2006/main"/>
         </p:blipFill>
         <p:spPr>
@@ -4356,7 +4442,7 @@
           <p:cNvPr id="4" name="">
             <a:extLst xmlns:a="http://schemas.openxmlformats.org/drawingml/2006/main">
               <a:ext uri="{FF2B5EF4-FFF2-40B4-BE49-F238E27FC236}">
-                <a16:creationId xmlns:a16="http://schemas.microsoft.com/office/drawing/2014/main" id="{12D5F2F8-1410-4109-82B7-5088EC22FBA5}"/>
+                <a16:creationId xmlns:a16="http://schemas.microsoft.com/office/drawing/2014/main" id="{C13133FE-CBDB-4BF7-A410-0F5214319BD5}"/>
               </a:ext>
             </a:extLst>
           </p:cNvPr>
@@ -4366,7 +4452,7 @@
           <p:nvPr/>
         </p:nvPicPr>
         <p:blipFill>
-          <a:blip xmlns:r="http://schemas.openxmlformats.org/officeDocument/2006/relationships" xmlns:a="http://schemas.openxmlformats.org/drawingml/2006/main" r:embed="R45f3b3b6944049e4"/>
+          <a:blip xmlns:r="http://schemas.openxmlformats.org/officeDocument/2006/relationships" xmlns:a="http://schemas.openxmlformats.org/drawingml/2006/main" r:embed="R727a7eb5b8714eb3"/>
           <a:stretch xmlns:a="http://schemas.openxmlformats.org/drawingml/2006/main"/>
         </p:blipFill>
         <p:spPr>
@@ -4384,7 +4470,7 @@
           <p:cNvPr id="5" name="">
             <a:extLst xmlns:a="http://schemas.openxmlformats.org/drawingml/2006/main">
               <a:ext uri="{FF2B5EF4-FFF2-40B4-BE49-F238E27FC236}">
-                <a16:creationId xmlns:a16="http://schemas.microsoft.com/office/drawing/2014/main" id="{E37148A0-67A0-42DF-A461-FA90875366F4}"/>
+                <a16:creationId xmlns:a16="http://schemas.microsoft.com/office/drawing/2014/main" id="{1D2A13E1-9C81-4DF3-BF9B-9E28E70AAA4E}"/>
               </a:ext>
             </a:extLst>
           </p:cNvPr>
@@ -4394,7 +4480,7 @@
           <p:nvPr/>
         </p:nvPicPr>
         <p:blipFill>
-          <a:blip xmlns:r="http://schemas.openxmlformats.org/officeDocument/2006/relationships" xmlns:a="http://schemas.openxmlformats.org/drawingml/2006/main" r:embed="R8a2ff6c4f6b24e2e"/>
+          <a:blip xmlns:r="http://schemas.openxmlformats.org/officeDocument/2006/relationships" xmlns:a="http://schemas.openxmlformats.org/drawingml/2006/main" r:embed="Rb1b9631f913b4174"/>
           <a:stretch xmlns:a="http://schemas.openxmlformats.org/drawingml/2006/main"/>
         </p:blipFill>
         <p:spPr>
@@ -4412,7 +4498,7 @@
           <p:cNvPr id="6" name="">
             <a:extLst xmlns:a="http://schemas.openxmlformats.org/drawingml/2006/main">
               <a:ext uri="{FF2B5EF4-FFF2-40B4-BE49-F238E27FC236}">
-                <a16:creationId xmlns:a16="http://schemas.microsoft.com/office/drawing/2014/main" id="{B176A5C8-4162-4017-85FC-E1A0EBEA4F6C}"/>
+                <a16:creationId xmlns:a16="http://schemas.microsoft.com/office/drawing/2014/main" id="{329EF3A2-78BB-446F-85D9-3766BD5266EC}"/>
               </a:ext>
             </a:extLst>
           </p:cNvPr>
@@ -4422,7 +4508,7 @@
           <p:nvPr/>
         </p:nvPicPr>
         <p:blipFill>
-          <a:blip xmlns:r="http://schemas.openxmlformats.org/officeDocument/2006/relationships" xmlns:a="http://schemas.openxmlformats.org/drawingml/2006/main" r:embed="Rec848205e8464aa6"/>
+          <a:blip xmlns:r="http://schemas.openxmlformats.org/officeDocument/2006/relationships" xmlns:a="http://schemas.openxmlformats.org/drawingml/2006/main" r:embed="Rc512c9c135584ed8"/>
           <a:stretch xmlns:a="http://schemas.openxmlformats.org/drawingml/2006/main"/>
         </p:blipFill>
         <p:spPr>
@@ -4440,7 +4526,7 @@
           <p:cNvPr id="7" name="">
             <a:extLst xmlns:a="http://schemas.openxmlformats.org/drawingml/2006/main">
               <a:ext uri="{FF2B5EF4-FFF2-40B4-BE49-F238E27FC236}">
-                <a16:creationId xmlns:a16="http://schemas.microsoft.com/office/drawing/2014/main" id="{43DC08A4-526A-4E6E-B9D4-42AE6B468C36}"/>
+                <a16:creationId xmlns:a16="http://schemas.microsoft.com/office/drawing/2014/main" id="{91A8D977-7440-4586-81AF-423F869EC679}"/>
               </a:ext>
             </a:extLst>
           </p:cNvPr>
@@ -4450,7 +4536,7 @@
           <p:nvPr/>
         </p:nvPicPr>
         <p:blipFill>
-          <a:blip xmlns:r="http://schemas.openxmlformats.org/officeDocument/2006/relationships" xmlns:a="http://schemas.openxmlformats.org/drawingml/2006/main" r:embed="R368b86f44bda4416"/>
+          <a:blip xmlns:r="http://schemas.openxmlformats.org/officeDocument/2006/relationships" xmlns:a="http://schemas.openxmlformats.org/drawingml/2006/main" r:embed="R973892687207401f"/>
           <a:stretch xmlns:a="http://schemas.openxmlformats.org/drawingml/2006/main"/>
         </p:blipFill>
         <p:spPr>
@@ -4468,7 +4554,7 @@
           <p:cNvPr id="8" name="">
             <a:extLst xmlns:a="http://schemas.openxmlformats.org/drawingml/2006/main">
               <a:ext uri="{FF2B5EF4-FFF2-40B4-BE49-F238E27FC236}">
-                <a16:creationId xmlns:a16="http://schemas.microsoft.com/office/drawing/2014/main" id="{FE95A5D7-1EED-40E1-959C-641E727D925C}"/>
+                <a16:creationId xmlns:a16="http://schemas.microsoft.com/office/drawing/2014/main" id="{F97064F4-0645-46A2-A80A-3EE4CB378F40}"/>
               </a:ext>
             </a:extLst>
           </p:cNvPr>
@@ -4478,7 +4564,7 @@
           <p:nvPr/>
         </p:nvPicPr>
         <p:blipFill>
-          <a:blip xmlns:r="http://schemas.openxmlformats.org/officeDocument/2006/relationships" xmlns:a="http://schemas.openxmlformats.org/drawingml/2006/main" r:embed="R36e5ecd3aa124d84"/>
+          <a:blip xmlns:r="http://schemas.openxmlformats.org/officeDocument/2006/relationships" xmlns:a="http://schemas.openxmlformats.org/drawingml/2006/main" r:embed="R4b6db3ee53ea4ba5"/>
           <a:stretch xmlns:a="http://schemas.openxmlformats.org/drawingml/2006/main"/>
         </p:blipFill>
         <p:spPr>
@@ -4496,7 +4582,7 @@
           <p:cNvPr id="9" name="">
             <a:extLst xmlns:a="http://schemas.openxmlformats.org/drawingml/2006/main">
               <a:ext uri="{FF2B5EF4-FFF2-40B4-BE49-F238E27FC236}">
-                <a16:creationId xmlns:a16="http://schemas.microsoft.com/office/drawing/2014/main" id="{DA66D894-2902-48A1-A21C-ABC313242544}"/>
+                <a16:creationId xmlns:a16="http://schemas.microsoft.com/office/drawing/2014/main" id="{49E497A4-3D06-4A79-86E6-8F4425FF16EE}"/>
               </a:ext>
             </a:extLst>
           </p:cNvPr>
@@ -4506,7 +4592,7 @@
           <p:nvPr/>
         </p:nvPicPr>
         <p:blipFill>
-          <a:blip xmlns:r="http://schemas.openxmlformats.org/officeDocument/2006/relationships" xmlns:a="http://schemas.openxmlformats.org/drawingml/2006/main" r:embed="Rea1b12f0ce3c4623"/>
+          <a:blip xmlns:r="http://schemas.openxmlformats.org/officeDocument/2006/relationships" xmlns:a="http://schemas.openxmlformats.org/drawingml/2006/main" r:embed="R9f1dbab82f674419"/>
           <a:stretch xmlns:a="http://schemas.openxmlformats.org/drawingml/2006/main"/>
         </p:blipFill>
         <p:spPr>
@@ -4524,7 +4610,7 @@
           <p:cNvPr id="10" name="">
             <a:extLst xmlns:a="http://schemas.openxmlformats.org/drawingml/2006/main">
               <a:ext uri="{FF2B5EF4-FFF2-40B4-BE49-F238E27FC236}">
-                <a16:creationId xmlns:a16="http://schemas.microsoft.com/office/drawing/2014/main" id="{CBB748C1-7ABE-4762-8A79-985FE3465F38}"/>
+                <a16:creationId xmlns:a16="http://schemas.microsoft.com/office/drawing/2014/main" id="{BD594682-041E-4E25-B684-0804F98C8FF1}"/>
               </a:ext>
             </a:extLst>
           </p:cNvPr>
@@ -4534,7 +4620,7 @@
           <p:nvPr/>
         </p:nvPicPr>
         <p:blipFill>
-          <a:blip xmlns:r="http://schemas.openxmlformats.org/officeDocument/2006/relationships" xmlns:a="http://schemas.openxmlformats.org/drawingml/2006/main" r:embed="Rf79f0c6e33e24eb7"/>
+          <a:blip xmlns:r="http://schemas.openxmlformats.org/officeDocument/2006/relationships" xmlns:a="http://schemas.openxmlformats.org/drawingml/2006/main" r:embed="Rc46ee52825f1445f"/>
           <a:stretch xmlns:a="http://schemas.openxmlformats.org/drawingml/2006/main"/>
         </p:blipFill>
         <p:spPr>
@@ -4552,7 +4638,7 @@
           <p:cNvPr id="11" name="">
             <a:extLst xmlns:a="http://schemas.openxmlformats.org/drawingml/2006/main">
               <a:ext uri="{FF2B5EF4-FFF2-40B4-BE49-F238E27FC236}">
-                <a16:creationId xmlns:a16="http://schemas.microsoft.com/office/drawing/2014/main" id="{76BE4A77-7781-47D0-AEED-422E124940A7}"/>
+                <a16:creationId xmlns:a16="http://schemas.microsoft.com/office/drawing/2014/main" id="{43C52292-E5D8-46D6-AFF2-2EBB278DFD56}"/>
               </a:ext>
             </a:extLst>
           </p:cNvPr>
@@ -4562,7 +4648,7 @@
           <p:nvPr/>
         </p:nvPicPr>
         <p:blipFill>
-          <a:blip xmlns:r="http://schemas.openxmlformats.org/officeDocument/2006/relationships" xmlns:a="http://schemas.openxmlformats.org/drawingml/2006/main" r:embed="R9ccbae20220145a1"/>
+          <a:blip xmlns:r="http://schemas.openxmlformats.org/officeDocument/2006/relationships" xmlns:a="http://schemas.openxmlformats.org/drawingml/2006/main" r:embed="R07bddc3056af455b"/>
           <a:stretch xmlns:a="http://schemas.openxmlformats.org/drawingml/2006/main"/>
         </p:blipFill>
         <p:spPr>
@@ -4580,7 +4666,7 @@
           <p:cNvPr id="12" name="speakers-span-1">
             <a:extLst xmlns:a="http://schemas.openxmlformats.org/drawingml/2006/main">
               <a:ext uri="{FF2B5EF4-FFF2-40B4-BE49-F238E27FC236}">
-                <a16:creationId xmlns:a16="http://schemas.microsoft.com/office/drawing/2014/main" id="{DF350AA2-2CF8-4510-B9DB-738C17C3AC25}"/>
+                <a16:creationId xmlns:a16="http://schemas.microsoft.com/office/drawing/2014/main" id="{5188545A-3E99-466E-96B2-C560C83BA252}"/>
               </a:ext>
             </a:extLst>
           </p:cNvPr>
@@ -4648,7 +4734,7 @@
           <p:cNvPr id="13" name="speakers-span-2">
             <a:extLst xmlns:a="http://schemas.openxmlformats.org/drawingml/2006/main">
               <a:ext uri="{FF2B5EF4-FFF2-40B4-BE49-F238E27FC236}">
-                <a16:creationId xmlns:a16="http://schemas.microsoft.com/office/drawing/2014/main" id="{521D4249-25D4-4540-923C-A706BDA6334D}"/>
+                <a16:creationId xmlns:a16="http://schemas.microsoft.com/office/drawing/2014/main" id="{FA6EFC93-5951-4155-9C7A-E4EC73581303}"/>
               </a:ext>
             </a:extLst>
           </p:cNvPr>
@@ -4716,7 +4802,7 @@
           <p:cNvPr id="14" name="speakers-h1-3">
             <a:extLst xmlns:a="http://schemas.openxmlformats.org/drawingml/2006/main">
               <a:ext uri="{FF2B5EF4-FFF2-40B4-BE49-F238E27FC236}">
-                <a16:creationId xmlns:a16="http://schemas.microsoft.com/office/drawing/2014/main" id="{5B84926D-FF13-4DAE-B37E-52A468DC5935}"/>
+                <a16:creationId xmlns:a16="http://schemas.microsoft.com/office/drawing/2014/main" id="{AF101B8D-B1C2-4561-9D10-7EFCB8C14F1E}"/>
               </a:ext>
             </a:extLst>
           </p:cNvPr>
@@ -4784,7 +4870,7 @@
           <p:cNvPr id="15" name="speakers-figcaption-4">
             <a:extLst xmlns:a="http://schemas.openxmlformats.org/drawingml/2006/main">
               <a:ext uri="{FF2B5EF4-FFF2-40B4-BE49-F238E27FC236}">
-                <a16:creationId xmlns:a16="http://schemas.microsoft.com/office/drawing/2014/main" id="{14DD7F47-B6B6-4831-A917-B63F301FB0A3}"/>
+                <a16:creationId xmlns:a16="http://schemas.microsoft.com/office/drawing/2014/main" id="{E8A9E794-D5C9-40EB-AB04-39DBB2E728B8}"/>
               </a:ext>
             </a:extLst>
           </p:cNvPr>
@@ -4852,7 +4938,7 @@
           <p:cNvPr id="16" name="speakers-figcaption-5">
             <a:extLst xmlns:a="http://schemas.openxmlformats.org/drawingml/2006/main">
               <a:ext uri="{FF2B5EF4-FFF2-40B4-BE49-F238E27FC236}">
-                <a16:creationId xmlns:a16="http://schemas.microsoft.com/office/drawing/2014/main" id="{AEFE08D2-DEE8-44EC-9776-8B88EC1DF633}"/>
+                <a16:creationId xmlns:a16="http://schemas.microsoft.com/office/drawing/2014/main" id="{5026922D-7B4B-4F38-9CFB-C073DB2B5482}"/>
               </a:ext>
             </a:extLst>
           </p:cNvPr>
@@ -4920,7 +5006,7 @@
           <p:cNvPr id="17" name="speakers-figcaption-6">
             <a:extLst xmlns:a="http://schemas.openxmlformats.org/drawingml/2006/main">
               <a:ext uri="{FF2B5EF4-FFF2-40B4-BE49-F238E27FC236}">
-                <a16:creationId xmlns:a16="http://schemas.microsoft.com/office/drawing/2014/main" id="{F62B661F-6A82-4625-8DDB-25EB85CDE511}"/>
+                <a16:creationId xmlns:a16="http://schemas.microsoft.com/office/drawing/2014/main" id="{0158C577-EE12-4F71-A8C9-874122CB446D}"/>
               </a:ext>
             </a:extLst>
           </p:cNvPr>
@@ -4988,7 +5074,7 @@
           <p:cNvPr id="18" name="speakers-figcaption-7">
             <a:extLst xmlns:a="http://schemas.openxmlformats.org/drawingml/2006/main">
               <a:ext uri="{FF2B5EF4-FFF2-40B4-BE49-F238E27FC236}">
-                <a16:creationId xmlns:a16="http://schemas.microsoft.com/office/drawing/2014/main" id="{EFC69D9A-E66E-4DD5-8472-746C01534A68}"/>
+                <a16:creationId xmlns:a16="http://schemas.microsoft.com/office/drawing/2014/main" id="{4A2CE043-C281-4177-AA3B-BE5035230F05}"/>
               </a:ext>
             </a:extLst>
           </p:cNvPr>
@@ -5056,7 +5142,7 @@
           <p:cNvPr id="19" name="speakers-figcaption-8">
             <a:extLst xmlns:a="http://schemas.openxmlformats.org/drawingml/2006/main">
               <a:ext uri="{FF2B5EF4-FFF2-40B4-BE49-F238E27FC236}">
-                <a16:creationId xmlns:a16="http://schemas.microsoft.com/office/drawing/2014/main" id="{A8B165DD-4024-4795-B169-07DEF0CB7BBA}"/>
+                <a16:creationId xmlns:a16="http://schemas.microsoft.com/office/drawing/2014/main" id="{0FBDBF58-3979-4F2A-903F-F775E507108B}"/>
               </a:ext>
             </a:extLst>
           </p:cNvPr>
@@ -5124,7 +5210,7 @@
           <p:cNvPr id="20" name="speakers-figcaption-9">
             <a:extLst xmlns:a="http://schemas.openxmlformats.org/drawingml/2006/main">
               <a:ext uri="{FF2B5EF4-FFF2-40B4-BE49-F238E27FC236}">
-                <a16:creationId xmlns:a16="http://schemas.microsoft.com/office/drawing/2014/main" id="{6D2AB994-E8DD-40F7-80C1-459DE8D66A77}"/>
+                <a16:creationId xmlns:a16="http://schemas.microsoft.com/office/drawing/2014/main" id="{D46A0D71-CF79-453F-A31B-A2872E253E62}"/>
               </a:ext>
             </a:extLst>
           </p:cNvPr>
@@ -5192,7 +5278,7 @@
           <p:cNvPr id="21" name="speakers-figcaption-10">
             <a:extLst xmlns:a="http://schemas.openxmlformats.org/drawingml/2006/main">
               <a:ext uri="{FF2B5EF4-FFF2-40B4-BE49-F238E27FC236}">
-                <a16:creationId xmlns:a16="http://schemas.microsoft.com/office/drawing/2014/main" id="{068E11AE-B22B-4479-82F8-FB232A8F04AF}"/>
+                <a16:creationId xmlns:a16="http://schemas.microsoft.com/office/drawing/2014/main" id="{95B4520C-0B65-4469-A529-E7F01A7EA731}"/>
               </a:ext>
             </a:extLst>
           </p:cNvPr>
@@ -5260,7 +5346,7 @@
           <p:cNvPr id="22" name="speakers-figcaption-11">
             <a:extLst xmlns:a="http://schemas.openxmlformats.org/drawingml/2006/main">
               <a:ext uri="{FF2B5EF4-FFF2-40B4-BE49-F238E27FC236}">
-                <a16:creationId xmlns:a16="http://schemas.microsoft.com/office/drawing/2014/main" id="{00DF2C72-F8CA-41FB-BF69-4B3D505BD570}"/>
+                <a16:creationId xmlns:a16="http://schemas.microsoft.com/office/drawing/2014/main" id="{6FA4D281-D9A9-4611-A076-FCB0F5100689}"/>
               </a:ext>
             </a:extLst>
           </p:cNvPr>
@@ -5328,7 +5414,7 @@
           <p:cNvPr id="23" name="speakers-figcaption-12">
             <a:extLst xmlns:a="http://schemas.openxmlformats.org/drawingml/2006/main">
               <a:ext uri="{FF2B5EF4-FFF2-40B4-BE49-F238E27FC236}">
-                <a16:creationId xmlns:a16="http://schemas.microsoft.com/office/drawing/2014/main" id="{38D2578D-4417-4C67-BB08-4FF74C19F7C4}"/>
+                <a16:creationId xmlns:a16="http://schemas.microsoft.com/office/drawing/2014/main" id="{2E569295-6F11-4C9E-9608-BDF0D64CAF56}"/>
               </a:ext>
             </a:extLst>
           </p:cNvPr>
@@ -5396,7 +5482,7 @@
           <p:cNvPr id="24" name="speakers-figcaption-13">
             <a:extLst xmlns:a="http://schemas.openxmlformats.org/drawingml/2006/main">
               <a:ext uri="{FF2B5EF4-FFF2-40B4-BE49-F238E27FC236}">
-                <a16:creationId xmlns:a16="http://schemas.microsoft.com/office/drawing/2014/main" id="{0F99577E-B22E-428F-9D2B-140B8789AC71}"/>
+                <a16:creationId xmlns:a16="http://schemas.microsoft.com/office/drawing/2014/main" id="{9520AA35-A7ED-4CB3-8F3B-F2C90A245247}"/>
               </a:ext>
             </a:extLst>
           </p:cNvPr>
@@ -5464,7 +5550,7 @@
           <p:cNvPr id="25" name="speakers-figcaption-14">
             <a:extLst xmlns:a="http://schemas.openxmlformats.org/drawingml/2006/main">
               <a:ext uri="{FF2B5EF4-FFF2-40B4-BE49-F238E27FC236}">
-                <a16:creationId xmlns:a16="http://schemas.microsoft.com/office/drawing/2014/main" id="{E1006AC2-18A6-4C6F-A7C8-70AD732EE477}"/>
+                <a16:creationId xmlns:a16="http://schemas.microsoft.com/office/drawing/2014/main" id="{959AEA5B-E05E-405F-90A6-EC8017142485}"/>
               </a:ext>
             </a:extLst>
           </p:cNvPr>
@@ -5532,7 +5618,7 @@
           <p:cNvPr id="26" name="speakers-span-15">
             <a:extLst xmlns:a="http://schemas.openxmlformats.org/drawingml/2006/main">
               <a:ext uri="{FF2B5EF4-FFF2-40B4-BE49-F238E27FC236}">
-                <a16:creationId xmlns:a16="http://schemas.microsoft.com/office/drawing/2014/main" id="{66FC5799-8435-443B-815B-0926A3619207}"/>
+                <a16:creationId xmlns:a16="http://schemas.microsoft.com/office/drawing/2014/main" id="{CB453EBD-0155-4BC7-BA62-FEAE424E3132}"/>
               </a:ext>
             </a:extLst>
           </p:cNvPr>
@@ -5600,19 +5686,19 @@
           <p:cNvPr id="27" name="speakers-span-16">
             <a:extLst xmlns:a="http://schemas.openxmlformats.org/drawingml/2006/main">
               <a:ext uri="{FF2B5EF4-FFF2-40B4-BE49-F238E27FC236}">
-                <a16:creationId xmlns:a16="http://schemas.microsoft.com/office/drawing/2014/main" id="{ACEB577C-E79F-4E9D-A8B5-AA6731D4CF46}"/>
-              </a:ext>
-            </a:extLst>
-          </p:cNvPr>
-          <p:cNvSpPr>
-            <a:spLocks xmlns:a="http://schemas.openxmlformats.org/drawingml/2006/main" noGrp="1"/>
-          </p:cNvSpPr>
-          <p:nvPr/>
-        </p:nvSpPr>
-        <p:spPr>
-          <a:xfrm xmlns:a="http://schemas.openxmlformats.org/drawingml/2006/main">
-            <a:off x="17005250" y="9440446"/>
-            <a:ext cx="688479" cy="230662"/>
+                <a16:creationId xmlns:a16="http://schemas.microsoft.com/office/drawing/2014/main" id="{64FB7DAF-8D71-4BFC-8964-B5CF4D2C4A1A}"/>
+              </a:ext>
+            </a:extLst>
+          </p:cNvPr>
+          <p:cNvSpPr>
+            <a:spLocks xmlns:a="http://schemas.openxmlformats.org/drawingml/2006/main" noGrp="1"/>
+          </p:cNvSpPr>
+          <p:nvPr/>
+        </p:nvSpPr>
+        <p:spPr>
+          <a:xfrm xmlns:a="http://schemas.openxmlformats.org/drawingml/2006/main">
+            <a:off x="17001083" y="9440446"/>
+            <a:ext cx="692646" cy="230662"/>
           </a:xfrm>
           <a:prstGeom xmlns:a="http://schemas.openxmlformats.org/drawingml/2006/main" prst="rect">
             <a:avLst/>
@@ -5658,7 +5744,7 @@
                 <a:ea typeface="Finlandica Text"/>
                 <a:cs typeface="Finlandica Text"/>
               </a:rPr>
-              <a:t>2 / 7</a:t>
+              <a:t>2 / 8</a:t>
             </a:r>
           </a:p>
         </p:txBody>
@@ -5666,7 +5752,7 @@
     </p:spTree>
     <p:extLst>
       <p:ext uri="{BB962C8B-B14F-4D97-AF65-F5344CB8AC3E}">
-        <p14:creationId xmlns:p14="http://schemas.microsoft.com/office/powerpoint/2010/main" val="1860672772"/>
+        <p14:creationId xmlns:p14="http://schemas.microsoft.com/office/powerpoint/2010/main" val="1675407977"/>
       </p:ext>
     </p:extLst>
   </p:cSld>
@@ -5697,7 +5783,7 @@
           <p:cNvPr id="18" name="">
             <a:extLst xmlns:a="http://schemas.openxmlformats.org/drawingml/2006/main">
               <a:ext uri="{FF2B5EF4-FFF2-40B4-BE49-F238E27FC236}">
-                <a16:creationId xmlns:a16="http://schemas.microsoft.com/office/drawing/2014/main" id="{E47F6ABC-1A7A-4378-928C-4BCA9C1D9EB8}"/>
+                <a16:creationId xmlns:a16="http://schemas.microsoft.com/office/drawing/2014/main" id="{CFA799D6-7F26-4125-AED8-0F37BF020156}"/>
               </a:ext>
             </a:extLst>
           </p:cNvPr>
@@ -5707,7 +5793,7 @@
           <p:nvPr/>
         </p:nvPicPr>
         <p:blipFill>
-          <a:blip xmlns:r="http://schemas.openxmlformats.org/officeDocument/2006/relationships" xmlns:a="http://schemas.openxmlformats.org/drawingml/2006/main" r:embed="Re3cc209940d64489"/>
+          <a:blip xmlns:r="http://schemas.openxmlformats.org/officeDocument/2006/relationships" xmlns:a="http://schemas.openxmlformats.org/drawingml/2006/main" r:embed="Rc8d618d4e9d54bac"/>
           <a:stretch xmlns:a="http://schemas.openxmlformats.org/drawingml/2006/main"/>
         </p:blipFill>
         <p:spPr>
@@ -5725,7 +5811,7 @@
           <p:cNvPr id="2" name="">
             <a:extLst xmlns:a="http://schemas.openxmlformats.org/drawingml/2006/main">
               <a:ext uri="{FF2B5EF4-FFF2-40B4-BE49-F238E27FC236}">
-                <a16:creationId xmlns:a16="http://schemas.microsoft.com/office/drawing/2014/main" id="{61F1CEFB-908A-42C2-95DC-4D41387BC2B5}"/>
+                <a16:creationId xmlns:a16="http://schemas.microsoft.com/office/drawing/2014/main" id="{860BBFD3-6629-48B0-90E2-952AB8F3C4AB}"/>
               </a:ext>
             </a:extLst>
           </p:cNvPr>
@@ -5735,7 +5821,7 @@
           <p:nvPr/>
         </p:nvPicPr>
         <p:blipFill>
-          <a:blip xmlns:r="http://schemas.openxmlformats.org/officeDocument/2006/relationships" xmlns:a="http://schemas.openxmlformats.org/drawingml/2006/main" r:embed="R56b9fdb53bb34b64"/>
+          <a:blip xmlns:r="http://schemas.openxmlformats.org/officeDocument/2006/relationships" xmlns:a="http://schemas.openxmlformats.org/drawingml/2006/main" r:embed="Rfd7e77a2cc8f4f75"/>
           <a:stretch xmlns:a="http://schemas.openxmlformats.org/drawingml/2006/main"/>
         </p:blipFill>
         <p:spPr>
@@ -5753,7 +5839,7 @@
           <p:cNvPr id="3" name="">
             <a:extLst xmlns:a="http://schemas.openxmlformats.org/drawingml/2006/main">
               <a:ext uri="{FF2B5EF4-FFF2-40B4-BE49-F238E27FC236}">
-                <a16:creationId xmlns:a16="http://schemas.microsoft.com/office/drawing/2014/main" id="{3CF53218-0FC1-4594-8C03-D568B7EE0BCA}"/>
+                <a16:creationId xmlns:a16="http://schemas.microsoft.com/office/drawing/2014/main" id="{143FF87B-107D-4ECD-A008-CB93D13BAB37}"/>
               </a:ext>
             </a:extLst>
           </p:cNvPr>
@@ -5763,7 +5849,7 @@
           <p:nvPr/>
         </p:nvPicPr>
         <p:blipFill>
-          <a:blip xmlns:r="http://schemas.openxmlformats.org/officeDocument/2006/relationships" xmlns:a="http://schemas.openxmlformats.org/drawingml/2006/main" r:embed="Rad6aa08b36a5418b"/>
+          <a:blip xmlns:r="http://schemas.openxmlformats.org/officeDocument/2006/relationships" xmlns:a="http://schemas.openxmlformats.org/drawingml/2006/main" r:embed="R9481a55f14304f8e"/>
           <a:stretch xmlns:a="http://schemas.openxmlformats.org/drawingml/2006/main"/>
         </p:blipFill>
         <p:spPr>
@@ -5781,7 +5867,7 @@
           <p:cNvPr id="4" name="">
             <a:extLst xmlns:a="http://schemas.openxmlformats.org/drawingml/2006/main">
               <a:ext uri="{FF2B5EF4-FFF2-40B4-BE49-F238E27FC236}">
-                <a16:creationId xmlns:a16="http://schemas.microsoft.com/office/drawing/2014/main" id="{532AC6A0-69AB-4850-948A-7439DCDD45FD}"/>
+                <a16:creationId xmlns:a16="http://schemas.microsoft.com/office/drawing/2014/main" id="{B4EB4F19-9BB6-4BF1-9098-99110E6F92C4}"/>
               </a:ext>
             </a:extLst>
           </p:cNvPr>
@@ -5791,7 +5877,7 @@
           <p:nvPr/>
         </p:nvPicPr>
         <p:blipFill>
-          <a:blip xmlns:r="http://schemas.openxmlformats.org/officeDocument/2006/relationships" xmlns:a="http://schemas.openxmlformats.org/drawingml/2006/main" r:embed="R40df9a86b1524739"/>
+          <a:blip xmlns:r="http://schemas.openxmlformats.org/officeDocument/2006/relationships" xmlns:a="http://schemas.openxmlformats.org/drawingml/2006/main" r:embed="Rf8392e4e42aa4005"/>
           <a:stretch xmlns:a="http://schemas.openxmlformats.org/drawingml/2006/main"/>
         </p:blipFill>
         <p:spPr>
@@ -5809,7 +5895,7 @@
           <p:cNvPr id="5" name="">
             <a:extLst xmlns:a="http://schemas.openxmlformats.org/drawingml/2006/main">
               <a:ext uri="{FF2B5EF4-FFF2-40B4-BE49-F238E27FC236}">
-                <a16:creationId xmlns:a16="http://schemas.microsoft.com/office/drawing/2014/main" id="{6EC033CE-9372-4A6A-A873-494B21E8E3A7}"/>
+                <a16:creationId xmlns:a16="http://schemas.microsoft.com/office/drawing/2014/main" id="{896DDA1B-E6E9-4D87-B94E-2A3F45325EF9}"/>
               </a:ext>
             </a:extLst>
           </p:cNvPr>
@@ -5819,7 +5905,7 @@
           <p:nvPr/>
         </p:nvPicPr>
         <p:blipFill>
-          <a:blip xmlns:r="http://schemas.openxmlformats.org/officeDocument/2006/relationships" xmlns:a="http://schemas.openxmlformats.org/drawingml/2006/main" r:embed="R6b6cd89164484fb2"/>
+          <a:blip xmlns:r="http://schemas.openxmlformats.org/officeDocument/2006/relationships" xmlns:a="http://schemas.openxmlformats.org/drawingml/2006/main" r:embed="R747816f3084c4d04"/>
           <a:stretch xmlns:a="http://schemas.openxmlformats.org/drawingml/2006/main"/>
         </p:blipFill>
         <p:spPr>
@@ -5837,7 +5923,7 @@
           <p:cNvPr id="6" name="">
             <a:extLst xmlns:a="http://schemas.openxmlformats.org/drawingml/2006/main">
               <a:ext uri="{FF2B5EF4-FFF2-40B4-BE49-F238E27FC236}">
-                <a16:creationId xmlns:a16="http://schemas.microsoft.com/office/drawing/2014/main" id="{9690D2B2-948F-4CE3-9D4B-4A4E4F66F2A5}"/>
+                <a16:creationId xmlns:a16="http://schemas.microsoft.com/office/drawing/2014/main" id="{3FDA5BAA-65FD-4A49-9A4A-43F66CC72CE1}"/>
               </a:ext>
             </a:extLst>
           </p:cNvPr>
@@ -5847,7 +5933,7 @@
           <p:nvPr/>
         </p:nvPicPr>
         <p:blipFill>
-          <a:blip xmlns:r="http://schemas.openxmlformats.org/officeDocument/2006/relationships" xmlns:a="http://schemas.openxmlformats.org/drawingml/2006/main" r:embed="R09768837688540d6"/>
+          <a:blip xmlns:r="http://schemas.openxmlformats.org/officeDocument/2006/relationships" xmlns:a="http://schemas.openxmlformats.org/drawingml/2006/main" r:embed="R311ba663d6474939"/>
           <a:stretch xmlns:a="http://schemas.openxmlformats.org/drawingml/2006/main"/>
         </p:blipFill>
         <p:spPr>
@@ -5865,7 +5951,7 @@
           <p:cNvPr id="7" name="">
             <a:extLst xmlns:a="http://schemas.openxmlformats.org/drawingml/2006/main">
               <a:ext uri="{FF2B5EF4-FFF2-40B4-BE49-F238E27FC236}">
-                <a16:creationId xmlns:a16="http://schemas.microsoft.com/office/drawing/2014/main" id="{DB65E0D1-37E6-4792-84B4-1392BC8D8466}"/>
+                <a16:creationId xmlns:a16="http://schemas.microsoft.com/office/drawing/2014/main" id="{27417529-A01B-4B3A-B31A-63E06BB1EC61}"/>
               </a:ext>
             </a:extLst>
           </p:cNvPr>
@@ -5875,7 +5961,7 @@
           <p:nvPr/>
         </p:nvPicPr>
         <p:blipFill>
-          <a:blip xmlns:r="http://schemas.openxmlformats.org/officeDocument/2006/relationships" xmlns:a="http://schemas.openxmlformats.org/drawingml/2006/main" r:embed="R8b6abac84d4a4c48"/>
+          <a:blip xmlns:r="http://schemas.openxmlformats.org/officeDocument/2006/relationships" xmlns:a="http://schemas.openxmlformats.org/drawingml/2006/main" r:embed="Rb3fa6c09739e44f1"/>
           <a:stretch xmlns:a="http://schemas.openxmlformats.org/drawingml/2006/main"/>
         </p:blipFill>
         <p:spPr>
@@ -5893,7 +5979,7 @@
           <p:cNvPr id="8" name="">
             <a:extLst xmlns:a="http://schemas.openxmlformats.org/drawingml/2006/main">
               <a:ext uri="{FF2B5EF4-FFF2-40B4-BE49-F238E27FC236}">
-                <a16:creationId xmlns:a16="http://schemas.microsoft.com/office/drawing/2014/main" id="{A78DBA02-FCA6-4617-8C3A-5579DEF3EBF5}"/>
+                <a16:creationId xmlns:a16="http://schemas.microsoft.com/office/drawing/2014/main" id="{901B37B7-4420-4865-9509-749D999EA1B0}"/>
               </a:ext>
             </a:extLst>
           </p:cNvPr>
@@ -5903,7 +5989,7 @@
           <p:nvPr/>
         </p:nvPicPr>
         <p:blipFill>
-          <a:blip xmlns:r="http://schemas.openxmlformats.org/officeDocument/2006/relationships" xmlns:a="http://schemas.openxmlformats.org/drawingml/2006/main" r:embed="Ra9ef5654fcfe4f49"/>
+          <a:blip xmlns:r="http://schemas.openxmlformats.org/officeDocument/2006/relationships" xmlns:a="http://schemas.openxmlformats.org/drawingml/2006/main" r:embed="R707fbe21bca74687"/>
           <a:stretch xmlns:a="http://schemas.openxmlformats.org/drawingml/2006/main"/>
         </p:blipFill>
         <p:spPr>
@@ -5921,7 +6007,7 @@
           <p:cNvPr id="9" name="sponsors-span-1">
             <a:extLst xmlns:a="http://schemas.openxmlformats.org/drawingml/2006/main">
               <a:ext uri="{FF2B5EF4-FFF2-40B4-BE49-F238E27FC236}">
-                <a16:creationId xmlns:a16="http://schemas.microsoft.com/office/drawing/2014/main" id="{0777B4EB-1834-49DC-A46F-3FC21CE22317}"/>
+                <a16:creationId xmlns:a16="http://schemas.microsoft.com/office/drawing/2014/main" id="{EE05C12E-5058-41E0-ABDB-332BA2321C03}"/>
               </a:ext>
             </a:extLst>
           </p:cNvPr>
@@ -5989,7 +6075,7 @@
           <p:cNvPr id="10" name="sponsors-span-2">
             <a:extLst xmlns:a="http://schemas.openxmlformats.org/drawingml/2006/main">
               <a:ext uri="{FF2B5EF4-FFF2-40B4-BE49-F238E27FC236}">
-                <a16:creationId xmlns:a16="http://schemas.microsoft.com/office/drawing/2014/main" id="{03605D3E-D261-4766-8BDB-CCDBAFAB26C8}"/>
+                <a16:creationId xmlns:a16="http://schemas.microsoft.com/office/drawing/2014/main" id="{28E4D7CA-7094-4DCA-9C7B-55F9701AA479}"/>
               </a:ext>
             </a:extLst>
           </p:cNvPr>
@@ -6057,7 +6143,7 @@
           <p:cNvPr id="11" name="sponsors-h1-3">
             <a:extLst xmlns:a="http://schemas.openxmlformats.org/drawingml/2006/main">
               <a:ext uri="{FF2B5EF4-FFF2-40B4-BE49-F238E27FC236}">
-                <a16:creationId xmlns:a16="http://schemas.microsoft.com/office/drawing/2014/main" id="{61B014AC-CCDA-494A-84CF-4A2D65F10B25}"/>
+                <a16:creationId xmlns:a16="http://schemas.microsoft.com/office/drawing/2014/main" id="{02C71418-99ED-4A32-971E-B63FCD93A2D7}"/>
               </a:ext>
             </a:extLst>
           </p:cNvPr>
@@ -6125,7 +6211,7 @@
           <p:cNvPr id="12" name="sponsors-h2-4">
             <a:extLst xmlns:a="http://schemas.openxmlformats.org/drawingml/2006/main">
               <a:ext uri="{FF2B5EF4-FFF2-40B4-BE49-F238E27FC236}">
-                <a16:creationId xmlns:a16="http://schemas.microsoft.com/office/drawing/2014/main" id="{D6C92E39-088E-464D-A560-32D5B485F1F6}"/>
+                <a16:creationId xmlns:a16="http://schemas.microsoft.com/office/drawing/2014/main" id="{0B42CE95-A942-45E8-86C7-0594BB995C7D}"/>
               </a:ext>
             </a:extLst>
           </p:cNvPr>
@@ -6193,7 +6279,7 @@
           <p:cNvPr id="13" name="sponsors-h2-5">
             <a:extLst xmlns:a="http://schemas.openxmlformats.org/drawingml/2006/main">
               <a:ext uri="{FF2B5EF4-FFF2-40B4-BE49-F238E27FC236}">
-                <a16:creationId xmlns:a16="http://schemas.microsoft.com/office/drawing/2014/main" id="{91D5BF1F-867C-4A82-9DB5-AB320343F288}"/>
+                <a16:creationId xmlns:a16="http://schemas.microsoft.com/office/drawing/2014/main" id="{31AE1B8A-1AB1-4126-8188-F8995EC1BF3C}"/>
               </a:ext>
             </a:extLst>
           </p:cNvPr>
@@ -6261,7 +6347,7 @@
           <p:cNvPr id="14" name="sponsors-h2-6">
             <a:extLst xmlns:a="http://schemas.openxmlformats.org/drawingml/2006/main">
               <a:ext uri="{FF2B5EF4-FFF2-40B4-BE49-F238E27FC236}">
-                <a16:creationId xmlns:a16="http://schemas.microsoft.com/office/drawing/2014/main" id="{FD13F0AF-0436-4AB2-BF4B-105688769C36}"/>
+                <a16:creationId xmlns:a16="http://schemas.microsoft.com/office/drawing/2014/main" id="{98FA783C-F23B-45A0-BC03-28A43CE68313}"/>
               </a:ext>
             </a:extLst>
           </p:cNvPr>
@@ -6329,7 +6415,7 @@
           <p:cNvPr id="15" name="sponsors-h2-7">
             <a:extLst xmlns:a="http://schemas.openxmlformats.org/drawingml/2006/main">
               <a:ext uri="{FF2B5EF4-FFF2-40B4-BE49-F238E27FC236}">
-                <a16:creationId xmlns:a16="http://schemas.microsoft.com/office/drawing/2014/main" id="{23A339A1-BF7B-4E0E-8E98-357A19DB825A}"/>
+                <a16:creationId xmlns:a16="http://schemas.microsoft.com/office/drawing/2014/main" id="{59FF965B-B6DB-47FC-BEE9-032509E235F4}"/>
               </a:ext>
             </a:extLst>
           </p:cNvPr>
@@ -6397,7 +6483,7 @@
           <p:cNvPr id="16" name="sponsors-span-8">
             <a:extLst xmlns:a="http://schemas.openxmlformats.org/drawingml/2006/main">
               <a:ext uri="{FF2B5EF4-FFF2-40B4-BE49-F238E27FC236}">
-                <a16:creationId xmlns:a16="http://schemas.microsoft.com/office/drawing/2014/main" id="{C632E479-7460-43A1-9542-00CCD9084451}"/>
+                <a16:creationId xmlns:a16="http://schemas.microsoft.com/office/drawing/2014/main" id="{9CD40AFE-49A9-48C6-8FAB-93A55DE9389E}"/>
               </a:ext>
             </a:extLst>
           </p:cNvPr>
@@ -6465,19 +6551,19 @@
           <p:cNvPr id="17" name="sponsors-span-9">
             <a:extLst xmlns:a="http://schemas.openxmlformats.org/drawingml/2006/main">
               <a:ext uri="{FF2B5EF4-FFF2-40B4-BE49-F238E27FC236}">
-                <a16:creationId xmlns:a16="http://schemas.microsoft.com/office/drawing/2014/main" id="{CF2E5992-6193-40A7-B716-D4EAEDF4F888}"/>
-              </a:ext>
-            </a:extLst>
-          </p:cNvPr>
-          <p:cNvSpPr>
-            <a:spLocks xmlns:a="http://schemas.openxmlformats.org/drawingml/2006/main" noGrp="1"/>
-          </p:cNvSpPr>
-          <p:nvPr/>
-        </p:nvSpPr>
-        <p:spPr>
-          <a:xfrm xmlns:a="http://schemas.openxmlformats.org/drawingml/2006/main">
-            <a:off x="16999297" y="9440446"/>
-            <a:ext cx="694432" cy="230662"/>
+                <a16:creationId xmlns:a16="http://schemas.microsoft.com/office/drawing/2014/main" id="{3EA91F19-9AB3-4CE6-8F70-011A1DB4835F}"/>
+              </a:ext>
+            </a:extLst>
+          </p:cNvPr>
+          <p:cNvSpPr>
+            <a:spLocks xmlns:a="http://schemas.openxmlformats.org/drawingml/2006/main" noGrp="1"/>
+          </p:cNvSpPr>
+          <p:nvPr/>
+        </p:nvSpPr>
+        <p:spPr>
+          <a:xfrm xmlns:a="http://schemas.openxmlformats.org/drawingml/2006/main">
+            <a:off x="16995130" y="9440446"/>
+            <a:ext cx="698599" cy="230662"/>
           </a:xfrm>
           <a:prstGeom xmlns:a="http://schemas.openxmlformats.org/drawingml/2006/main" prst="rect">
             <a:avLst/>
@@ -6523,7 +6609,7 @@
                 <a:ea typeface="Finlandica Text"/>
                 <a:cs typeface="Finlandica Text"/>
               </a:rPr>
-              <a:t>3 / 7</a:t>
+              <a:t>3 / 8</a:t>
             </a:r>
           </a:p>
         </p:txBody>
@@ -6531,7 +6617,7 @@
     </p:spTree>
     <p:extLst>
       <p:ext uri="{BB962C8B-B14F-4D97-AF65-F5344CB8AC3E}">
-        <p14:creationId xmlns:p14="http://schemas.microsoft.com/office/powerpoint/2010/main" val="1411427221"/>
+        <p14:creationId xmlns:p14="http://schemas.microsoft.com/office/powerpoint/2010/main" val="1433740177"/>
       </p:ext>
     </p:extLst>
   </p:cSld>
@@ -6562,7 +6648,7 @@
           <p:cNvPr id="11" name="">
             <a:extLst xmlns:a="http://schemas.openxmlformats.org/drawingml/2006/main">
               <a:ext uri="{FF2B5EF4-FFF2-40B4-BE49-F238E27FC236}">
-                <a16:creationId xmlns:a16="http://schemas.microsoft.com/office/drawing/2014/main" id="{38B76C54-F79D-42BE-AF98-659FC931639E}"/>
+                <a16:creationId xmlns:a16="http://schemas.microsoft.com/office/drawing/2014/main" id="{32258C28-FD3E-4D54-B724-DA399D710EB2}"/>
               </a:ext>
             </a:extLst>
           </p:cNvPr>
@@ -6572,7 +6658,7 @@
           <p:nvPr/>
         </p:nvPicPr>
         <p:blipFill>
-          <a:blip xmlns:r="http://schemas.openxmlformats.org/officeDocument/2006/relationships" xmlns:a="http://schemas.openxmlformats.org/drawingml/2006/main" r:embed="R409c3af8bcb4415e"/>
+          <a:blip xmlns:r="http://schemas.openxmlformats.org/officeDocument/2006/relationships" xmlns:a="http://schemas.openxmlformats.org/drawingml/2006/main" r:embed="R07c8ae5a124d43c4"/>
           <a:stretch xmlns:a="http://schemas.openxmlformats.org/drawingml/2006/main"/>
         </p:blipFill>
         <p:spPr>
@@ -6590,7 +6676,7 @@
           <p:cNvPr id="2" name="crew-span-1">
             <a:extLst xmlns:a="http://schemas.openxmlformats.org/drawingml/2006/main">
               <a:ext uri="{FF2B5EF4-FFF2-40B4-BE49-F238E27FC236}">
-                <a16:creationId xmlns:a16="http://schemas.microsoft.com/office/drawing/2014/main" id="{3D53995D-69B3-4F43-AE9E-A5353C4C2B9A}"/>
+                <a16:creationId xmlns:a16="http://schemas.microsoft.com/office/drawing/2014/main" id="{F16CB683-A4CD-473A-A893-ADFAD436392A}"/>
               </a:ext>
             </a:extLst>
           </p:cNvPr>
@@ -6658,7 +6744,7 @@
           <p:cNvPr id="3" name="crew-span-2">
             <a:extLst xmlns:a="http://schemas.openxmlformats.org/drawingml/2006/main">
               <a:ext uri="{FF2B5EF4-FFF2-40B4-BE49-F238E27FC236}">
-                <a16:creationId xmlns:a16="http://schemas.microsoft.com/office/drawing/2014/main" id="{E58E2DA0-8447-47C3-940F-AECCAED82AAB}"/>
+                <a16:creationId xmlns:a16="http://schemas.microsoft.com/office/drawing/2014/main" id="{16F87D2E-2C69-4132-90A5-7E4306FE21CC}"/>
               </a:ext>
             </a:extLst>
           </p:cNvPr>
@@ -6726,7 +6812,7 @@
           <p:cNvPr id="4" name="crew-p-3">
             <a:extLst xmlns:a="http://schemas.openxmlformats.org/drawingml/2006/main">
               <a:ext uri="{FF2B5EF4-FFF2-40B4-BE49-F238E27FC236}">
-                <a16:creationId xmlns:a16="http://schemas.microsoft.com/office/drawing/2014/main" id="{9F25EC20-344C-4C56-B0EB-77229A0C9D46}"/>
+                <a16:creationId xmlns:a16="http://schemas.microsoft.com/office/drawing/2014/main" id="{B9FEB099-BF55-4DF0-8BE4-43957F3A3B64}"/>
               </a:ext>
             </a:extLst>
           </p:cNvPr>
@@ -6794,7 +6880,7 @@
           <p:cNvPr id="5" name="crew-h1-4">
             <a:extLst xmlns:a="http://schemas.openxmlformats.org/drawingml/2006/main">
               <a:ext uri="{FF2B5EF4-FFF2-40B4-BE49-F238E27FC236}">
-                <a16:creationId xmlns:a16="http://schemas.microsoft.com/office/drawing/2014/main" id="{1DBBE904-804E-4200-BAAA-B71CC56C1776}"/>
+                <a16:creationId xmlns:a16="http://schemas.microsoft.com/office/drawing/2014/main" id="{7746F7BC-17EF-4EC7-9C69-EC45794A9B19}"/>
               </a:ext>
             </a:extLst>
           </p:cNvPr>
@@ -6862,7 +6948,7 @@
           <p:cNvPr id="6" name="crew-h1-5">
             <a:extLst xmlns:a="http://schemas.openxmlformats.org/drawingml/2006/main">
               <a:ext uri="{FF2B5EF4-FFF2-40B4-BE49-F238E27FC236}">
-                <a16:creationId xmlns:a16="http://schemas.microsoft.com/office/drawing/2014/main" id="{2528CDAF-D308-4B09-8B0D-31A24EBC756B}"/>
+                <a16:creationId xmlns:a16="http://schemas.microsoft.com/office/drawing/2014/main" id="{63B02184-0ED0-4322-9D1F-1D0C2B20DDEF}"/>
               </a:ext>
             </a:extLst>
           </p:cNvPr>
@@ -6930,7 +7016,7 @@
           <p:cNvPr id="7" name="crew-p-6">
             <a:extLst xmlns:a="http://schemas.openxmlformats.org/drawingml/2006/main">
               <a:ext uri="{FF2B5EF4-FFF2-40B4-BE49-F238E27FC236}">
-                <a16:creationId xmlns:a16="http://schemas.microsoft.com/office/drawing/2014/main" id="{B18DFA0B-91C0-4DF4-90BC-2969DC4B9787}"/>
+                <a16:creationId xmlns:a16="http://schemas.microsoft.com/office/drawing/2014/main" id="{CA934017-A104-4688-B9E0-5B92F4E25484}"/>
               </a:ext>
             </a:extLst>
           </p:cNvPr>
@@ -6998,7 +7084,7 @@
           <p:cNvPr id="8" name="crew-p-7">
             <a:extLst xmlns:a="http://schemas.openxmlformats.org/drawingml/2006/main">
               <a:ext uri="{FF2B5EF4-FFF2-40B4-BE49-F238E27FC236}">
-                <a16:creationId xmlns:a16="http://schemas.microsoft.com/office/drawing/2014/main" id="{7F075FF8-DCD0-42A3-A3A4-0AC7C1D9B8C4}"/>
+                <a16:creationId xmlns:a16="http://schemas.microsoft.com/office/drawing/2014/main" id="{E0E9F2FE-BD0C-499D-8A55-A09DFA549FA3}"/>
               </a:ext>
             </a:extLst>
           </p:cNvPr>
@@ -7066,7 +7152,7 @@
           <p:cNvPr id="9" name="crew-span-8">
             <a:extLst xmlns:a="http://schemas.openxmlformats.org/drawingml/2006/main">
               <a:ext uri="{FF2B5EF4-FFF2-40B4-BE49-F238E27FC236}">
-                <a16:creationId xmlns:a16="http://schemas.microsoft.com/office/drawing/2014/main" id="{58D04BF3-71D8-4E9F-A7F1-A2163D272C46}"/>
+                <a16:creationId xmlns:a16="http://schemas.microsoft.com/office/drawing/2014/main" id="{1680E397-15D8-48F7-8895-4B1B1976FF9D}"/>
               </a:ext>
             </a:extLst>
           </p:cNvPr>
@@ -7134,19 +7220,19 @@
           <p:cNvPr id="10" name="crew-span-9">
             <a:extLst xmlns:a="http://schemas.openxmlformats.org/drawingml/2006/main">
               <a:ext uri="{FF2B5EF4-FFF2-40B4-BE49-F238E27FC236}">
-                <a16:creationId xmlns:a16="http://schemas.microsoft.com/office/drawing/2014/main" id="{FF26B93E-D345-4496-AD37-BB0102717D71}"/>
-              </a:ext>
-            </a:extLst>
-          </p:cNvPr>
-          <p:cNvSpPr>
-            <a:spLocks xmlns:a="http://schemas.openxmlformats.org/drawingml/2006/main" noGrp="1"/>
-          </p:cNvSpPr>
-          <p:nvPr/>
-        </p:nvSpPr>
-        <p:spPr>
-          <a:xfrm xmlns:a="http://schemas.openxmlformats.org/drawingml/2006/main">
-            <a:off x="17000934" y="9440446"/>
-            <a:ext cx="692795" cy="230662"/>
+                <a16:creationId xmlns:a16="http://schemas.microsoft.com/office/drawing/2014/main" id="{533FC938-40F6-4188-810C-2C6285825AC9}"/>
+              </a:ext>
+            </a:extLst>
+          </p:cNvPr>
+          <p:cNvSpPr>
+            <a:spLocks xmlns:a="http://schemas.openxmlformats.org/drawingml/2006/main" noGrp="1"/>
+          </p:cNvSpPr>
+          <p:nvPr/>
+        </p:nvSpPr>
+        <p:spPr>
+          <a:xfrm xmlns:a="http://schemas.openxmlformats.org/drawingml/2006/main">
+            <a:off x="16996767" y="9440446"/>
+            <a:ext cx="696962" cy="230662"/>
           </a:xfrm>
           <a:prstGeom xmlns:a="http://schemas.openxmlformats.org/drawingml/2006/main" prst="rect">
             <a:avLst/>
@@ -7192,7 +7278,7 @@
                 <a:ea typeface="Finlandica Text"/>
                 <a:cs typeface="Finlandica Text"/>
               </a:rPr>
-              <a:t>4 / 7</a:t>
+              <a:t>4 / 8</a:t>
             </a:r>
           </a:p>
         </p:txBody>
@@ -7200,7 +7286,7 @@
     </p:spTree>
     <p:extLst>
       <p:ext uri="{BB962C8B-B14F-4D97-AF65-F5344CB8AC3E}">
-        <p14:creationId xmlns:p14="http://schemas.microsoft.com/office/powerpoint/2010/main" val="736613529"/>
+        <p14:creationId xmlns:p14="http://schemas.microsoft.com/office/powerpoint/2010/main" val="2011185281"/>
       </p:ext>
     </p:extLst>
   </p:cSld>
@@ -7231,7 +7317,7 @@
           <p:cNvPr id="10" name="">
             <a:extLst xmlns:a="http://schemas.openxmlformats.org/drawingml/2006/main">
               <a:ext uri="{FF2B5EF4-FFF2-40B4-BE49-F238E27FC236}">
-                <a16:creationId xmlns:a16="http://schemas.microsoft.com/office/drawing/2014/main" id="{8DE3E8FD-2202-458E-A4B3-9D5BD5902BCE}"/>
+                <a16:creationId xmlns:a16="http://schemas.microsoft.com/office/drawing/2014/main" id="{44026586-6B4B-4362-9BF0-9A5522C4EFCE}"/>
               </a:ext>
             </a:extLst>
           </p:cNvPr>
@@ -7241,7 +7327,7 @@
           <p:nvPr/>
         </p:nvPicPr>
         <p:blipFill>
-          <a:blip xmlns:r="http://schemas.openxmlformats.org/officeDocument/2006/relationships" xmlns:a="http://schemas.openxmlformats.org/drawingml/2006/main" r:embed="R2ebaf48bf4f444c3"/>
+          <a:blip xmlns:r="http://schemas.openxmlformats.org/officeDocument/2006/relationships" xmlns:a="http://schemas.openxmlformats.org/drawingml/2006/main" r:embed="R62d01bf12b964202"/>
           <a:stretch xmlns:a="http://schemas.openxmlformats.org/drawingml/2006/main"/>
         </p:blipFill>
         <p:spPr>
@@ -7259,7 +7345,7 @@
           <p:cNvPr id="2" name="attendees-span-1">
             <a:extLst xmlns:a="http://schemas.openxmlformats.org/drawingml/2006/main">
               <a:ext uri="{FF2B5EF4-FFF2-40B4-BE49-F238E27FC236}">
-                <a16:creationId xmlns:a16="http://schemas.microsoft.com/office/drawing/2014/main" id="{CAAA94F0-F548-4433-9AA4-8EF303B3AB3E}"/>
+                <a16:creationId xmlns:a16="http://schemas.microsoft.com/office/drawing/2014/main" id="{BECD00A6-1DC3-429F-A63C-2244C4952D0E}"/>
               </a:ext>
             </a:extLst>
           </p:cNvPr>
@@ -7327,7 +7413,7 @@
           <p:cNvPr id="3" name="attendees-span-2">
             <a:extLst xmlns:a="http://schemas.openxmlformats.org/drawingml/2006/main">
               <a:ext uri="{FF2B5EF4-FFF2-40B4-BE49-F238E27FC236}">
-                <a16:creationId xmlns:a16="http://schemas.microsoft.com/office/drawing/2014/main" id="{22F049A3-BCD4-4BB2-90B2-B66E5A61D0AA}"/>
+                <a16:creationId xmlns:a16="http://schemas.microsoft.com/office/drawing/2014/main" id="{0FDB5980-35E3-44E5-BF5D-C326A551A310}"/>
               </a:ext>
             </a:extLst>
           </p:cNvPr>
@@ -7395,7 +7481,7 @@
           <p:cNvPr id="4" name="attendees-p-3">
             <a:extLst xmlns:a="http://schemas.openxmlformats.org/drawingml/2006/main">
               <a:ext uri="{FF2B5EF4-FFF2-40B4-BE49-F238E27FC236}">
-                <a16:creationId xmlns:a16="http://schemas.microsoft.com/office/drawing/2014/main" id="{A05E67CD-7662-44F3-BE44-113B895C8B26}"/>
+                <a16:creationId xmlns:a16="http://schemas.microsoft.com/office/drawing/2014/main" id="{CBE5A955-0587-41C8-A425-EB85B0893A3F}"/>
               </a:ext>
             </a:extLst>
           </p:cNvPr>
@@ -7463,7 +7549,7 @@
           <p:cNvPr id="5" name="attendees-h1-4">
             <a:extLst xmlns:a="http://schemas.openxmlformats.org/drawingml/2006/main">
               <a:ext uri="{FF2B5EF4-FFF2-40B4-BE49-F238E27FC236}">
-                <a16:creationId xmlns:a16="http://schemas.microsoft.com/office/drawing/2014/main" id="{1ADD1638-2713-45C4-9A9D-4C3B9A33A554}"/>
+                <a16:creationId xmlns:a16="http://schemas.microsoft.com/office/drawing/2014/main" id="{0E03AB55-96C4-4328-915A-34D1A4104C5F}"/>
               </a:ext>
             </a:extLst>
           </p:cNvPr>
@@ -7531,7 +7617,7 @@
           <p:cNvPr id="6" name="attendees-h1-5">
             <a:extLst xmlns:a="http://schemas.openxmlformats.org/drawingml/2006/main">
               <a:ext uri="{FF2B5EF4-FFF2-40B4-BE49-F238E27FC236}">
-                <a16:creationId xmlns:a16="http://schemas.microsoft.com/office/drawing/2014/main" id="{5B494E6C-F044-49AF-9B0F-BADB03738499}"/>
+                <a16:creationId xmlns:a16="http://schemas.microsoft.com/office/drawing/2014/main" id="{7215BA12-99D2-4D0F-96A6-9C2F988EC52B}"/>
               </a:ext>
             </a:extLst>
           </p:cNvPr>
@@ -7599,7 +7685,7 @@
           <p:cNvPr id="7" name="attendees-p-6">
             <a:extLst xmlns:a="http://schemas.openxmlformats.org/drawingml/2006/main">
               <a:ext uri="{FF2B5EF4-FFF2-40B4-BE49-F238E27FC236}">
-                <a16:creationId xmlns:a16="http://schemas.microsoft.com/office/drawing/2014/main" id="{9D1A5C17-A646-4FC1-A14E-041E29C6C287}"/>
+                <a16:creationId xmlns:a16="http://schemas.microsoft.com/office/drawing/2014/main" id="{F160B0F5-B734-4C31-A6EF-F087F799AB19}"/>
               </a:ext>
             </a:extLst>
           </p:cNvPr>
@@ -7667,7 +7753,7 @@
           <p:cNvPr id="8" name="attendees-span-7">
             <a:extLst xmlns:a="http://schemas.openxmlformats.org/drawingml/2006/main">
               <a:ext uri="{FF2B5EF4-FFF2-40B4-BE49-F238E27FC236}">
-                <a16:creationId xmlns:a16="http://schemas.microsoft.com/office/drawing/2014/main" id="{78A189EC-70F9-48E1-95C4-D76DFB61713D}"/>
+                <a16:creationId xmlns:a16="http://schemas.microsoft.com/office/drawing/2014/main" id="{11BA2303-FF41-4B59-8B33-7B0AC9DAC14C}"/>
               </a:ext>
             </a:extLst>
           </p:cNvPr>
@@ -7735,19 +7821,19 @@
           <p:cNvPr id="9" name="attendees-span-8">
             <a:extLst xmlns:a="http://schemas.openxmlformats.org/drawingml/2006/main">
               <a:ext uri="{FF2B5EF4-FFF2-40B4-BE49-F238E27FC236}">
-                <a16:creationId xmlns:a16="http://schemas.microsoft.com/office/drawing/2014/main" id="{233039B4-DC01-4ED0-9526-261301556DDB}"/>
-              </a:ext>
-            </a:extLst>
-          </p:cNvPr>
-          <p:cNvSpPr>
-            <a:spLocks xmlns:a="http://schemas.openxmlformats.org/drawingml/2006/main" noGrp="1"/>
-          </p:cNvSpPr>
-          <p:nvPr/>
-        </p:nvSpPr>
-        <p:spPr>
-          <a:xfrm xmlns:a="http://schemas.openxmlformats.org/drawingml/2006/main">
-            <a:off x="17001976" y="9440446"/>
-            <a:ext cx="691753" cy="230662"/>
+                <a16:creationId xmlns:a16="http://schemas.microsoft.com/office/drawing/2014/main" id="{4859D824-AA16-4209-8684-5CD3EC716572}"/>
+              </a:ext>
+            </a:extLst>
+          </p:cNvPr>
+          <p:cNvSpPr>
+            <a:spLocks xmlns:a="http://schemas.openxmlformats.org/drawingml/2006/main" noGrp="1"/>
+          </p:cNvSpPr>
+          <p:nvPr/>
+        </p:nvSpPr>
+        <p:spPr>
+          <a:xfrm xmlns:a="http://schemas.openxmlformats.org/drawingml/2006/main">
+            <a:off x="16997809" y="9440446"/>
+            <a:ext cx="695920" cy="230662"/>
           </a:xfrm>
           <a:prstGeom xmlns:a="http://schemas.openxmlformats.org/drawingml/2006/main" prst="rect">
             <a:avLst/>
@@ -7793,7 +7879,7 @@
                 <a:ea typeface="Finlandica Text"/>
                 <a:cs typeface="Finlandica Text"/>
               </a:rPr>
-              <a:t>5 / 7</a:t>
+              <a:t>5 / 8</a:t>
             </a:r>
           </a:p>
         </p:txBody>
@@ -7801,7 +7887,7 @@
     </p:spTree>
     <p:extLst>
       <p:ext uri="{BB962C8B-B14F-4D97-AF65-F5344CB8AC3E}">
-        <p14:creationId xmlns:p14="http://schemas.microsoft.com/office/powerpoint/2010/main" val="681596335"/>
+        <p14:creationId xmlns:p14="http://schemas.microsoft.com/office/powerpoint/2010/main" val="128558922"/>
       </p:ext>
     </p:extLst>
   </p:cSld>
@@ -7832,7 +7918,7 @@
           <p:cNvPr id="7" name="">
             <a:extLst xmlns:a="http://schemas.openxmlformats.org/drawingml/2006/main">
               <a:ext uri="{FF2B5EF4-FFF2-40B4-BE49-F238E27FC236}">
-                <a16:creationId xmlns:a16="http://schemas.microsoft.com/office/drawing/2014/main" id="{09AD8B73-94E0-45B5-ACBE-EBA69C82E026}"/>
+                <a16:creationId xmlns:a16="http://schemas.microsoft.com/office/drawing/2014/main" id="{BCC6C42C-63FE-49F9-85A9-804E79C1757A}"/>
               </a:ext>
             </a:extLst>
           </p:cNvPr>
@@ -7842,7 +7928,7 @@
           <p:nvPr/>
         </p:nvPicPr>
         <p:blipFill>
-          <a:blip xmlns:r="http://schemas.openxmlformats.org/officeDocument/2006/relationships" xmlns:a="http://schemas.openxmlformats.org/drawingml/2006/main" r:embed="Rf2c91c26afb24479"/>
+          <a:blip xmlns:r="http://schemas.openxmlformats.org/officeDocument/2006/relationships" xmlns:a="http://schemas.openxmlformats.org/drawingml/2006/main" r:embed="R82660c4114af4331"/>
           <a:stretch xmlns:a="http://schemas.openxmlformats.org/drawingml/2006/main"/>
         </p:blipFill>
         <p:spPr>
@@ -7860,7 +7946,7 @@
           <p:cNvPr id="2" name="group-photo-span-1">
             <a:extLst xmlns:a="http://schemas.openxmlformats.org/drawingml/2006/main">
               <a:ext uri="{FF2B5EF4-FFF2-40B4-BE49-F238E27FC236}">
-                <a16:creationId xmlns:a16="http://schemas.microsoft.com/office/drawing/2014/main" id="{B3240F7E-56C7-4CA3-B2C5-3A5D85EB6406}"/>
+                <a16:creationId xmlns:a16="http://schemas.microsoft.com/office/drawing/2014/main" id="{757D3800-0237-47A1-9991-6E79933B9BBC}"/>
               </a:ext>
             </a:extLst>
           </p:cNvPr>
@@ -7928,7 +8014,7 @@
           <p:cNvPr id="3" name="group-photo-span-2">
             <a:extLst xmlns:a="http://schemas.openxmlformats.org/drawingml/2006/main">
               <a:ext uri="{FF2B5EF4-FFF2-40B4-BE49-F238E27FC236}">
-                <a16:creationId xmlns:a16="http://schemas.microsoft.com/office/drawing/2014/main" id="{08DB6E29-8064-4ED4-9D96-523EBF4B3E9E}"/>
+                <a16:creationId xmlns:a16="http://schemas.microsoft.com/office/drawing/2014/main" id="{BB33D3EB-E7E9-4D50-88CC-A1C0ED13BDE7}"/>
               </a:ext>
             </a:extLst>
           </p:cNvPr>
@@ -7996,7 +8082,7 @@
           <p:cNvPr id="4" name="group-photo-h1-3">
             <a:extLst xmlns:a="http://schemas.openxmlformats.org/drawingml/2006/main">
               <a:ext uri="{FF2B5EF4-FFF2-40B4-BE49-F238E27FC236}">
-                <a16:creationId xmlns:a16="http://schemas.microsoft.com/office/drawing/2014/main" id="{DD9EE2E7-7447-4953-ACA4-94786654BCCD}"/>
+                <a16:creationId xmlns:a16="http://schemas.microsoft.com/office/drawing/2014/main" id="{6CC917F5-14E3-4916-84A9-84C9352F0E28}"/>
               </a:ext>
             </a:extLst>
           </p:cNvPr>
@@ -8064,7 +8150,7 @@
           <p:cNvPr id="5" name="group-photo-span-4">
             <a:extLst xmlns:a="http://schemas.openxmlformats.org/drawingml/2006/main">
               <a:ext uri="{FF2B5EF4-FFF2-40B4-BE49-F238E27FC236}">
-                <a16:creationId xmlns:a16="http://schemas.microsoft.com/office/drawing/2014/main" id="{D451F15C-EA40-47F0-88D9-BB50F37BAC33}"/>
+                <a16:creationId xmlns:a16="http://schemas.microsoft.com/office/drawing/2014/main" id="{A75CE70C-9B3C-49CC-8C54-32C65FF95E21}"/>
               </a:ext>
             </a:extLst>
           </p:cNvPr>
@@ -8132,19 +8218,19 @@
           <p:cNvPr id="6" name="group-photo-span-5">
             <a:extLst xmlns:a="http://schemas.openxmlformats.org/drawingml/2006/main">
               <a:ext uri="{FF2B5EF4-FFF2-40B4-BE49-F238E27FC236}">
-                <a16:creationId xmlns:a16="http://schemas.microsoft.com/office/drawing/2014/main" id="{3DD3534B-F7F8-408E-8720-79B6564E34F0}"/>
-              </a:ext>
-            </a:extLst>
-          </p:cNvPr>
-          <p:cNvSpPr>
-            <a:spLocks xmlns:a="http://schemas.openxmlformats.org/drawingml/2006/main" noGrp="1"/>
-          </p:cNvSpPr>
-          <p:nvPr/>
-        </p:nvSpPr>
-        <p:spPr>
-          <a:xfrm xmlns:a="http://schemas.openxmlformats.org/drawingml/2006/main">
-            <a:off x="16996916" y="9440446"/>
-            <a:ext cx="696813" cy="230662"/>
+                <a16:creationId xmlns:a16="http://schemas.microsoft.com/office/drawing/2014/main" id="{01B8A571-5FD2-43FB-B382-5A36585F00F6}"/>
+              </a:ext>
+            </a:extLst>
+          </p:cNvPr>
+          <p:cNvSpPr>
+            <a:spLocks xmlns:a="http://schemas.openxmlformats.org/drawingml/2006/main" noGrp="1"/>
+          </p:cNvSpPr>
+          <p:nvPr/>
+        </p:nvSpPr>
+        <p:spPr>
+          <a:xfrm xmlns:a="http://schemas.openxmlformats.org/drawingml/2006/main">
+            <a:off x="16992749" y="9440446"/>
+            <a:ext cx="700980" cy="230662"/>
           </a:xfrm>
           <a:prstGeom xmlns:a="http://schemas.openxmlformats.org/drawingml/2006/main" prst="rect">
             <a:avLst/>
@@ -8190,7 +8276,7 @@
                 <a:ea typeface="Finlandica Text"/>
                 <a:cs typeface="Finlandica Text"/>
               </a:rPr>
-              <a:t>6 / 7</a:t>
+              <a:t>6 / 8</a:t>
             </a:r>
           </a:p>
         </p:txBody>
@@ -8198,7 +8284,7 @@
     </p:spTree>
     <p:extLst>
       <p:ext uri="{BB962C8B-B14F-4D97-AF65-F5344CB8AC3E}">
-        <p14:creationId xmlns:p14="http://schemas.microsoft.com/office/powerpoint/2010/main" val="1991610602"/>
+        <p14:creationId xmlns:p14="http://schemas.microsoft.com/office/powerpoint/2010/main" val="1420521289"/>
       </p:ext>
     </p:extLst>
   </p:cSld>
@@ -8226,10 +8312,10 @@
       </p:grpSpPr>
       <p:pic>
         <p:nvPicPr>
-          <p:cNvPr id="10" name="">
-            <a:extLst xmlns:a="http://schemas.openxmlformats.org/drawingml/2006/main">
-              <a:ext uri="{FF2B5EF4-FFF2-40B4-BE49-F238E27FC236}">
-                <a16:creationId xmlns:a16="http://schemas.microsoft.com/office/drawing/2014/main" id="{FC13EC08-9550-49CE-A5A1-FB4AF4A81AA8}"/>
+          <p:cNvPr id="3" name="">
+            <a:extLst xmlns:a="http://schemas.openxmlformats.org/drawingml/2006/main">
+              <a:ext uri="{FF2B5EF4-FFF2-40B4-BE49-F238E27FC236}">
+                <a16:creationId xmlns:a16="http://schemas.microsoft.com/office/drawing/2014/main" id="{A1890B9F-6947-41B7-BE3D-AB78EC72648C}"/>
               </a:ext>
             </a:extLst>
           </p:cNvPr>
@@ -8239,7 +8325,7 @@
           <p:nvPr/>
         </p:nvPicPr>
         <p:blipFill>
-          <a:blip xmlns:r="http://schemas.openxmlformats.org/officeDocument/2006/relationships" xmlns:a="http://schemas.openxmlformats.org/drawingml/2006/main" r:embed="R9a5fa50aeff94aa7"/>
+          <a:blip xmlns:r="http://schemas.openxmlformats.org/officeDocument/2006/relationships" xmlns:a="http://schemas.openxmlformats.org/drawingml/2006/main" r:embed="R838553be59684fcf"/>
           <a:stretch xmlns:a="http://schemas.openxmlformats.org/drawingml/2006/main"/>
         </p:blipFill>
         <p:spPr>
@@ -8257,7 +8343,7 @@
           <p:cNvPr id="2" name="">
             <a:extLst xmlns:a="http://schemas.openxmlformats.org/drawingml/2006/main">
               <a:ext uri="{FF2B5EF4-FFF2-40B4-BE49-F238E27FC236}">
-                <a16:creationId xmlns:a16="http://schemas.microsoft.com/office/drawing/2014/main" id="{9933B6FB-8880-4143-8556-B92D316F2848}"/>
+                <a16:creationId xmlns:a16="http://schemas.microsoft.com/office/drawing/2014/main" id="{550DDFC7-008D-401A-B264-6BCA5E56EB8F}"/>
               </a:ext>
             </a:extLst>
           </p:cNvPr>
@@ -8267,11 +8353,96 @@
           <p:nvPr/>
         </p:nvPicPr>
         <p:blipFill>
-          <a:blip xmlns:r="http://schemas.openxmlformats.org/officeDocument/2006/relationships" xmlns:a="http://schemas.openxmlformats.org/drawingml/2006/main" r:embed="Radf2488cdc894272"/>
+          <a:blip xmlns:r="http://schemas.openxmlformats.org/officeDocument/2006/relationships" xmlns:a="http://schemas.openxmlformats.org/drawingml/2006/main" r:embed="R334c8fb093614332"/>
           <a:stretch xmlns:a="http://schemas.openxmlformats.org/drawingml/2006/main"/>
         </p:blipFill>
         <p:spPr>
           <a:xfrm xmlns:a="http://schemas.openxmlformats.org/drawingml/2006/main">
+            <a:off x="6148388" y="2202061"/>
+            <a:ext cx="5991076" cy="5991076"/>
+          </a:xfrm>
+          <a:prstGeom xmlns:a="http://schemas.openxmlformats.org/drawingml/2006/main" prst="rect">
+            <a:avLst/>
+          </a:prstGeom>
+        </p:spPr>
+      </p:pic>
+    </p:spTree>
+    <p:extLst>
+      <p:ext uri="{BB962C8B-B14F-4D97-AF65-F5344CB8AC3E}">
+        <p14:creationId xmlns:p14="http://schemas.microsoft.com/office/powerpoint/2010/main" val="1145302061"/>
+      </p:ext>
+    </p:extLst>
+  </p:cSld>
+</p:sld>
+</file>
+
+<file path=ppt/slides/slide8.xml><?xml version="1.0" encoding="utf-8"?>
+<p:sld xmlns:p="http://schemas.openxmlformats.org/presentationml/2006/main">
+  <p:cSld>
+    <p:bg>
+      <p:bgPr>
+        <a:solidFill xmlns:a="http://schemas.openxmlformats.org/drawingml/2006/main">
+          <a:srgbClr val="080808"/>
+        </a:solidFill>
+      </p:bgPr>
+    </p:bg>
+    <p:spTree>
+      <p:nvGrpSpPr>
+        <p:cNvPr id="1" name=""/>
+        <p:cNvGrpSpPr/>
+        <p:nvPr/>
+      </p:nvGrpSpPr>
+      <p:grpSpPr>
+        <a:xfrm xmlns:a="http://schemas.openxmlformats.org/drawingml/2006/main"/>
+      </p:grpSpPr>
+      <p:pic>
+        <p:nvPicPr>
+          <p:cNvPr id="10" name="">
+            <a:extLst xmlns:a="http://schemas.openxmlformats.org/drawingml/2006/main">
+              <a:ext uri="{FF2B5EF4-FFF2-40B4-BE49-F238E27FC236}">
+                <a16:creationId xmlns:a16="http://schemas.microsoft.com/office/drawing/2014/main" id="{C4FA5070-E5B7-46D6-81E6-000738114CAB}"/>
+              </a:ext>
+            </a:extLst>
+          </p:cNvPr>
+          <p:cNvPicPr>
+            <a:picLocks xmlns:a="http://schemas.openxmlformats.org/drawingml/2006/main" noChangeAspect="1"/>
+          </p:cNvPicPr>
+          <p:nvPr/>
+        </p:nvPicPr>
+        <p:blipFill>
+          <a:blip xmlns:r="http://schemas.openxmlformats.org/officeDocument/2006/relationships" xmlns:a="http://schemas.openxmlformats.org/drawingml/2006/main" r:embed="R9f5fcefd9dd942a4"/>
+          <a:stretch xmlns:a="http://schemas.openxmlformats.org/drawingml/2006/main"/>
+        </p:blipFill>
+        <p:spPr>
+          <a:xfrm xmlns:a="http://schemas.openxmlformats.org/drawingml/2006/main">
+            <a:off x="0" y="0"/>
+            <a:ext cx="18288000" cy="10287000"/>
+          </a:xfrm>
+          <a:prstGeom xmlns:a="http://schemas.openxmlformats.org/drawingml/2006/main" prst="rect">
+            <a:avLst/>
+          </a:prstGeom>
+        </p:spPr>
+      </p:pic>
+      <p:pic>
+        <p:nvPicPr>
+          <p:cNvPr id="2" name="">
+            <a:extLst xmlns:a="http://schemas.openxmlformats.org/drawingml/2006/main">
+              <a:ext uri="{FF2B5EF4-FFF2-40B4-BE49-F238E27FC236}">
+                <a16:creationId xmlns:a16="http://schemas.microsoft.com/office/drawing/2014/main" id="{9E49A020-3A00-4C5B-9918-0BBA5373FC9B}"/>
+              </a:ext>
+            </a:extLst>
+          </p:cNvPr>
+          <p:cNvPicPr>
+            <a:picLocks xmlns:a="http://schemas.openxmlformats.org/drawingml/2006/main" noChangeAspect="1"/>
+          </p:cNvPicPr>
+          <p:nvPr/>
+        </p:nvPicPr>
+        <p:blipFill>
+          <a:blip xmlns:r="http://schemas.openxmlformats.org/officeDocument/2006/relationships" xmlns:a="http://schemas.openxmlformats.org/drawingml/2006/main" r:embed="R6f56c8c9928a448d"/>
+          <a:stretch xmlns:a="http://schemas.openxmlformats.org/drawingml/2006/main"/>
+        </p:blipFill>
+        <p:spPr>
+          <a:xfrm xmlns:a="http://schemas.openxmlformats.org/drawingml/2006/main">
             <a:off x="824441" y="2701230"/>
             <a:ext cx="6019635" cy="4992588"/>
           </a:xfrm>
@@ -8285,7 +8456,7 @@
           <p:cNvPr id="3" name="afterparty-span-1">
             <a:extLst xmlns:a="http://schemas.openxmlformats.org/drawingml/2006/main">
               <a:ext uri="{FF2B5EF4-FFF2-40B4-BE49-F238E27FC236}">
-                <a16:creationId xmlns:a16="http://schemas.microsoft.com/office/drawing/2014/main" id="{0FC8A857-745D-483B-B609-C40D57417265}"/>
+                <a16:creationId xmlns:a16="http://schemas.microsoft.com/office/drawing/2014/main" id="{8744AA83-3B73-41C2-82B5-8EB9719D56F5}"/>
               </a:ext>
             </a:extLst>
           </p:cNvPr>
@@ -8353,7 +8524,7 @@
           <p:cNvPr id="4" name="afterparty-span-2">
             <a:extLst xmlns:a="http://schemas.openxmlformats.org/drawingml/2006/main">
               <a:ext uri="{FF2B5EF4-FFF2-40B4-BE49-F238E27FC236}">
-                <a16:creationId xmlns:a16="http://schemas.microsoft.com/office/drawing/2014/main" id="{8288761D-CD51-499F-ABCB-57737026A9CD}"/>
+                <a16:creationId xmlns:a16="http://schemas.microsoft.com/office/drawing/2014/main" id="{8BBDDF0E-B48F-4038-9D17-3B749FB97A92}"/>
               </a:ext>
             </a:extLst>
           </p:cNvPr>
@@ -8421,7 +8592,7 @@
           <p:cNvPr id="5" name="afterparty-h1-3">
             <a:extLst xmlns:a="http://schemas.openxmlformats.org/drawingml/2006/main">
               <a:ext uri="{FF2B5EF4-FFF2-40B4-BE49-F238E27FC236}">
-                <a16:creationId xmlns:a16="http://schemas.microsoft.com/office/drawing/2014/main" id="{0405FB43-27E4-46D4-8F54-E2E546F17F62}"/>
+                <a16:creationId xmlns:a16="http://schemas.microsoft.com/office/drawing/2014/main" id="{50DFDF86-783C-468F-AFF0-23C972E9D712}"/>
               </a:ext>
             </a:extLst>
           </p:cNvPr>
@@ -8489,7 +8660,7 @@
           <p:cNvPr id="6" name="afterparty-p-4">
             <a:extLst xmlns:a="http://schemas.openxmlformats.org/drawingml/2006/main">
               <a:ext uri="{FF2B5EF4-FFF2-40B4-BE49-F238E27FC236}">
-                <a16:creationId xmlns:a16="http://schemas.microsoft.com/office/drawing/2014/main" id="{0AD068A4-9685-48D8-8F90-F85BA8A0C845}"/>
+                <a16:creationId xmlns:a16="http://schemas.microsoft.com/office/drawing/2014/main" id="{B1FCA448-22BB-4015-B6CF-21D344303EB2}"/>
               </a:ext>
             </a:extLst>
           </p:cNvPr>
@@ -8557,7 +8728,7 @@
           <p:cNvPr id="7" name="afterparty-p-5">
             <a:extLst xmlns:a="http://schemas.openxmlformats.org/drawingml/2006/main">
               <a:ext uri="{FF2B5EF4-FFF2-40B4-BE49-F238E27FC236}">
-                <a16:creationId xmlns:a16="http://schemas.microsoft.com/office/drawing/2014/main" id="{FE747769-F11F-44DB-BACB-9C7BA51FBCDF}"/>
+                <a16:creationId xmlns:a16="http://schemas.microsoft.com/office/drawing/2014/main" id="{3382DAFE-41F4-487E-A729-0C290E1AC5E8}"/>
               </a:ext>
             </a:extLst>
           </p:cNvPr>
@@ -8625,7 +8796,7 @@
           <p:cNvPr id="8" name="afterparty-span-6">
             <a:extLst xmlns:a="http://schemas.openxmlformats.org/drawingml/2006/main">
               <a:ext uri="{FF2B5EF4-FFF2-40B4-BE49-F238E27FC236}">
-                <a16:creationId xmlns:a16="http://schemas.microsoft.com/office/drawing/2014/main" id="{F3C37A0B-3CF2-483C-B39C-D7FE6948A992}"/>
+                <a16:creationId xmlns:a16="http://schemas.microsoft.com/office/drawing/2014/main" id="{1B41AF9E-E736-4347-8C9A-569CF3AA03BA}"/>
               </a:ext>
             </a:extLst>
           </p:cNvPr>
@@ -8693,19 +8864,19 @@
           <p:cNvPr id="9" name="afterparty-span-7">
             <a:extLst xmlns:a="http://schemas.openxmlformats.org/drawingml/2006/main">
               <a:ext uri="{FF2B5EF4-FFF2-40B4-BE49-F238E27FC236}">
-                <a16:creationId xmlns:a16="http://schemas.microsoft.com/office/drawing/2014/main" id="{BFB05592-0AD9-400D-B4CF-D38442F8C19C}"/>
-              </a:ext>
-            </a:extLst>
-          </p:cNvPr>
-          <p:cNvSpPr>
-            <a:spLocks xmlns:a="http://schemas.openxmlformats.org/drawingml/2006/main" noGrp="1"/>
-          </p:cNvSpPr>
-          <p:nvPr/>
-        </p:nvSpPr>
-        <p:spPr>
-          <a:xfrm xmlns:a="http://schemas.openxmlformats.org/drawingml/2006/main">
-            <a:off x="16999000" y="9440446"/>
-            <a:ext cx="694730" cy="230662"/>
+                <a16:creationId xmlns:a16="http://schemas.microsoft.com/office/drawing/2014/main" id="{DE84D131-27D4-49F4-AB61-D87A8BC1FF9C}"/>
+              </a:ext>
+            </a:extLst>
+          </p:cNvPr>
+          <p:cNvSpPr>
+            <a:spLocks xmlns:a="http://schemas.openxmlformats.org/drawingml/2006/main" noGrp="1"/>
+          </p:cNvSpPr>
+          <p:nvPr/>
+        </p:nvSpPr>
+        <p:spPr>
+          <a:xfrm xmlns:a="http://schemas.openxmlformats.org/drawingml/2006/main">
+            <a:off x="16990516" y="9440446"/>
+            <a:ext cx="703213" cy="230662"/>
           </a:xfrm>
           <a:prstGeom xmlns:a="http://schemas.openxmlformats.org/drawingml/2006/main" prst="rect">
             <a:avLst/>
@@ -8751,7 +8922,7 @@
                 <a:ea typeface="Finlandica Text"/>
                 <a:cs typeface="Finlandica Text"/>
               </a:rPr>
-              <a:t>7 / 7</a:t>
+              <a:t>8 / 8</a:t>
             </a:r>
           </a:p>
         </p:txBody>
@@ -8759,7 +8930,7 @@
     </p:spTree>
     <p:extLst>
       <p:ext uri="{BB962C8B-B14F-4D97-AF65-F5344CB8AC3E}">
-        <p14:creationId xmlns:p14="http://schemas.microsoft.com/office/powerpoint/2010/main" val="1508723983"/>
+        <p14:creationId xmlns:p14="http://schemas.microsoft.com/office/powerpoint/2010/main" val="535735069"/>
       </p:ext>
     </p:extLst>
   </p:cSld>

</xml_diff>